<commit_message>
Expand business model into a multi-stream revenue section
Replace the single revenue card with a portfolio view: two new slides
covering eight revenue streams (FPGA modules/dev kits, porting
services, non-dilutive funding, NRE, compiler subscription, license
fees, royalties, future chiplet) and a three-phase revenue timeline
with the royalty-lag and services-cap discipline stated explicitly.
Deck grows from 16 to 18 slides.

Co-Authored-By: Claude Fable 5 <noreply@anthropic.com>
Claude-Session: https://claude.ai/code/session_01TsLisZDc9LkYDtDHVhoeAT
</commit_message>
<xml_diff>
--- a/deck/RIA_Deck_v1.pptx
+++ b/deck/RIA_Deck_v1.pptx
@@ -21,6 +21,8 @@
     <p:sldId id="269" r:id="rId20"/>
     <p:sldId id="270" r:id="rId21"/>
     <p:sldId id="271" r:id="rId22"/>
+    <p:sldId id="272" r:id="rId23"/>
+    <p:sldId id="273" r:id="rId24"/>
   </p:sldIdLst>
   <p:sldSz cx="12191695" cy="6858000" type="screen4x3"/>
   <p:notesSz cx="6858000" cy="9144000"/>
@@ -6062,7 +6064,7 @@
                 </a:solidFill>
                 <a:latin typeface="Calibri"/>
               </a:rPr>
-              <a:t>License fee per design win, per-unit royalty on shipped SoCs, annual compiler &amp; toolchain subscription, NRE for customer-specific tile-mix configuration.</a:t>
+              <a:t>A portfolio, not a single stream: product revenue from year 1 (FPGA modules, services), licensing engine compounding from year 3 — detailed on the next two slides.</a:t>
             </a:r>
           </a:p>
         </p:txBody>
@@ -6365,7 +6367,7 @@
                 </a:solidFill>
                 <a:latin typeface="Calibri"/>
               </a:rPr>
-              <a:t>EXECUTION</a:t>
+              <a:t>BUSINESS</a:t>
             </a:r>
           </a:p>
         </p:txBody>
@@ -6404,7 +6406,7 @@
                 </a:solidFill>
                 <a:latin typeface="Calibri"/>
               </a:rPr>
-              <a:t>Roadmap — milestones, not checkmarks</a:t>
+              <a:t>Revenue is a portfolio — eight streams, one product</a:t>
             </a:r>
           </a:p>
         </p:txBody>
@@ -6531,691 +6533,853 @@
           </a:p>
         </p:txBody>
       </p:sp>
-      <p:sp>
-        <p:nvSpPr>
-          <p:cNvPr id="8" name="Rounded Rectangle 7"/>
-          <p:cNvSpPr/>
-          <p:nvPr/>
-        </p:nvSpPr>
-        <p:spPr>
-          <a:xfrm>
-            <a:off x="548640" y="1554480"/>
-            <a:ext cx="2679192" cy="3291840"/>
-          </a:xfrm>
-          <a:prstGeom prst="roundRect">
-            <a:avLst>
-              <a:gd name="adj" fmla="val 4500"/>
-            </a:avLst>
-          </a:prstGeom>
-          <a:solidFill>
-            <a:srgbClr val="F2F5F8"/>
-          </a:solidFill>
-          <a:ln w="12700">
-            <a:solidFill>
-              <a:srgbClr val="D4DCE4"/>
-            </a:solidFill>
-          </a:ln>
-          <a:effectLst/>
-        </p:spPr>
-        <p:style>
-          <a:lnRef idx="1">
-            <a:schemeClr val="accent1"/>
-          </a:lnRef>
-          <a:fillRef idx="3">
-            <a:schemeClr val="accent1"/>
-          </a:fillRef>
-          <a:effectRef idx="2">
-            <a:schemeClr val="accent1"/>
-          </a:effectRef>
-          <a:fontRef idx="minor">
-            <a:schemeClr val="lt1"/>
-          </a:fontRef>
-        </p:style>
-        <p:txBody>
-          <a:bodyPr rtlCol="0" anchor="t" wrap="square" lIns="164592" rIns="164592" tIns="164592" bIns="164592"/>
-          <a:lstStyle/>
-          <a:p>
-            <a:pPr algn="l">
-              <a:spcAft>
-                <a:spcPts val="300"/>
-              </a:spcAft>
-            </a:pPr>
-            <a:r>
-              <a:rPr sz="1050" b="1">
-                <a:solidFill>
-                  <a:srgbClr val="2E86AB"/>
-                </a:solidFill>
-                <a:latin typeface="Calibri"/>
-              </a:rPr>
-              <a:t>Phase 1  •  months 0–6</a:t>
-            </a:r>
-          </a:p>
-          <a:p>
-            <a:pPr algn="l">
-              <a:spcAft>
-                <a:spcPts val="1000"/>
-              </a:spcAft>
-            </a:pPr>
-            <a:r>
-              <a:rPr sz="1700" b="1">
-                <a:solidFill>
-                  <a:srgbClr val="0F2442"/>
-                </a:solidFill>
-                <a:latin typeface="Calibri"/>
-              </a:rPr>
-              <a:t>Foundations</a:t>
-            </a:r>
-          </a:p>
-          <a:p>
-            <a:pPr algn="l">
-              <a:spcAft>
-                <a:spcPts val="700"/>
-              </a:spcAft>
-            </a:pPr>
-            <a:r>
-              <a:rPr sz="1150" b="0">
-                <a:solidFill>
-                  <a:srgbClr val="5B6676"/>
-                </a:solidFill>
-                <a:latin typeface="Calibri"/>
-              </a:rPr>
-              <a:t>•  Tile RTL + ISA specification frozen</a:t>
-            </a:r>
-          </a:p>
-          <a:p>
-            <a:pPr algn="l">
-              <a:spcAft>
-                <a:spcPts val="700"/>
-              </a:spcAft>
-            </a:pPr>
-            <a:r>
-              <a:rPr sz="1150" b="0">
-                <a:solidFill>
-                  <a:srgbClr val="5B6676"/>
-                </a:solidFill>
-                <a:latin typeface="Calibri"/>
-              </a:rPr>
-              <a:t>•  Single-tile FPGA validation (GEMM, conv, vector ops)</a:t>
-            </a:r>
-          </a:p>
-          <a:p>
-            <a:pPr algn="l">
-              <a:spcAft>
-                <a:spcPts val="700"/>
-              </a:spcAft>
-            </a:pPr>
-            <a:r>
-              <a:rPr sz="1150" b="0">
-                <a:solidFill>
-                  <a:srgbClr val="5B6676"/>
-                </a:solidFill>
-                <a:latin typeface="Calibri"/>
-              </a:rPr>
-              <a:t>•  Compiler MVP: ONNX → microcode for core opset</a:t>
-            </a:r>
-          </a:p>
-        </p:txBody>
-      </p:sp>
-      <p:sp>
-        <p:nvSpPr>
-          <p:cNvPr id="9" name="Rectangle 8"/>
-          <p:cNvSpPr/>
-          <p:nvPr/>
-        </p:nvSpPr>
-        <p:spPr>
-          <a:xfrm>
-            <a:off x="548640" y="1554480"/>
-            <a:ext cx="2679192" cy="64008"/>
-          </a:xfrm>
-          <a:prstGeom prst="rect">
-            <a:avLst/>
-          </a:prstGeom>
-          <a:solidFill>
-            <a:srgbClr val="2E86AB"/>
-          </a:solidFill>
-          <a:ln>
-            <a:noFill/>
-          </a:ln>
-          <a:effectLst/>
-        </p:spPr>
-        <p:style>
-          <a:lnRef idx="1">
-            <a:schemeClr val="accent1"/>
-          </a:lnRef>
-          <a:fillRef idx="3">
-            <a:schemeClr val="accent1"/>
-          </a:fillRef>
-          <a:effectRef idx="2">
-            <a:schemeClr val="accent1"/>
-          </a:effectRef>
-          <a:fontRef idx="minor">
-            <a:schemeClr val="lt1"/>
-          </a:fontRef>
-        </p:style>
-        <p:txBody>
-          <a:bodyPr rtlCol="0" anchor="ctr"/>
-          <a:lstStyle/>
-          <a:p>
-            <a:pPr algn="ctr"/>
-          </a:p>
-        </p:txBody>
-      </p:sp>
-      <p:sp>
-        <p:nvSpPr>
-          <p:cNvPr id="10" name="Rounded Rectangle 9"/>
-          <p:cNvSpPr/>
-          <p:nvPr/>
-        </p:nvSpPr>
-        <p:spPr>
-          <a:xfrm>
-            <a:off x="3355848" y="1554480"/>
-            <a:ext cx="2679192" cy="3291840"/>
-          </a:xfrm>
-          <a:prstGeom prst="roundRect">
-            <a:avLst>
-              <a:gd name="adj" fmla="val 4500"/>
-            </a:avLst>
-          </a:prstGeom>
-          <a:solidFill>
-            <a:srgbClr val="F2F5F8"/>
-          </a:solidFill>
-          <a:ln w="12700">
-            <a:solidFill>
-              <a:srgbClr val="D4DCE4"/>
-            </a:solidFill>
-          </a:ln>
-          <a:effectLst/>
-        </p:spPr>
-        <p:style>
-          <a:lnRef idx="1">
-            <a:schemeClr val="accent1"/>
-          </a:lnRef>
-          <a:fillRef idx="3">
-            <a:schemeClr val="accent1"/>
-          </a:fillRef>
-          <a:effectRef idx="2">
-            <a:schemeClr val="accent1"/>
-          </a:effectRef>
-          <a:fontRef idx="minor">
-            <a:schemeClr val="lt1"/>
-          </a:fontRef>
-        </p:style>
-        <p:txBody>
-          <a:bodyPr rtlCol="0" anchor="t" wrap="square" lIns="164592" rIns="164592" tIns="164592" bIns="164592"/>
-          <a:lstStyle/>
-          <a:p>
-            <a:pPr algn="l">
-              <a:spcAft>
-                <a:spcPts val="300"/>
-              </a:spcAft>
-            </a:pPr>
-            <a:r>
-              <a:rPr sz="1050" b="1">
-                <a:solidFill>
-                  <a:srgbClr val="2E86AB"/>
-                </a:solidFill>
-                <a:latin typeface="Calibri"/>
-              </a:rPr>
-              <a:t>Phase 2  •  months 6–12</a:t>
-            </a:r>
-          </a:p>
-          <a:p>
-            <a:pPr algn="l">
-              <a:spcAft>
-                <a:spcPts val="1000"/>
-              </a:spcAft>
-            </a:pPr>
-            <a:r>
-              <a:rPr sz="1700" b="1">
-                <a:solidFill>
-                  <a:srgbClr val="0F2442"/>
-                </a:solidFill>
-                <a:latin typeface="Calibri"/>
-              </a:rPr>
-              <a:t>Fabric</a:t>
-            </a:r>
-          </a:p>
-          <a:p>
-            <a:pPr algn="l">
-              <a:spcAft>
-                <a:spcPts val="700"/>
-              </a:spcAft>
-            </a:pPr>
-            <a:r>
-              <a:rPr sz="1150" b="0">
-                <a:solidFill>
-                  <a:srgbClr val="5B6676"/>
-                </a:solidFill>
-                <a:latin typeface="Calibri"/>
-              </a:rPr>
-              <a:t>•  Multi-tile array + NoC + scheduler subsystem</a:t>
-            </a:r>
-          </a:p>
-          <a:p>
-            <a:pPr algn="l">
-              <a:spcAft>
-                <a:spcPts val="700"/>
-              </a:spcAft>
-            </a:pPr>
-            <a:r>
-              <a:rPr sz="1150" b="0">
-                <a:solidFill>
-                  <a:srgbClr val="5B6676"/>
-                </a:solidFill>
-                <a:latin typeface="Calibri"/>
-              </a:rPr>
-              <a:t>•  MobileNetV2 end-to-end on FPGA</a:t>
-            </a:r>
-          </a:p>
-          <a:p>
-            <a:pPr algn="l">
-              <a:spcAft>
-                <a:spcPts val="700"/>
-              </a:spcAft>
-            </a:pPr>
-            <a:r>
-              <a:rPr sz="1150" b="0">
-                <a:solidFill>
-                  <a:srgbClr val="5B6676"/>
-                </a:solidFill>
-                <a:latin typeface="Calibri"/>
-              </a:rPr>
-              <a:t>•  First utilization + power measurements</a:t>
-            </a:r>
-          </a:p>
-        </p:txBody>
-      </p:sp>
-      <p:sp>
-        <p:nvSpPr>
-          <p:cNvPr id="11" name="Rectangle 10"/>
-          <p:cNvSpPr/>
-          <p:nvPr/>
-        </p:nvSpPr>
-        <p:spPr>
-          <a:xfrm>
-            <a:off x="3355848" y="1554480"/>
-            <a:ext cx="2679192" cy="64008"/>
-          </a:xfrm>
-          <a:prstGeom prst="rect">
-            <a:avLst/>
-          </a:prstGeom>
-          <a:solidFill>
-            <a:srgbClr val="2E86AB"/>
-          </a:solidFill>
-          <a:ln>
-            <a:noFill/>
-          </a:ln>
-          <a:effectLst/>
-        </p:spPr>
-        <p:style>
-          <a:lnRef idx="1">
-            <a:schemeClr val="accent1"/>
-          </a:lnRef>
-          <a:fillRef idx="3">
-            <a:schemeClr val="accent1"/>
-          </a:fillRef>
-          <a:effectRef idx="2">
-            <a:schemeClr val="accent1"/>
-          </a:effectRef>
-          <a:fontRef idx="minor">
-            <a:schemeClr val="lt1"/>
-          </a:fontRef>
-        </p:style>
-        <p:txBody>
-          <a:bodyPr rtlCol="0" anchor="ctr"/>
-          <a:lstStyle/>
-          <a:p>
-            <a:pPr algn="ctr"/>
-          </a:p>
-        </p:txBody>
-      </p:sp>
-      <p:sp>
-        <p:nvSpPr>
-          <p:cNvPr id="12" name="Rounded Rectangle 11"/>
-          <p:cNvSpPr/>
-          <p:nvPr/>
-        </p:nvSpPr>
-        <p:spPr>
-          <a:xfrm>
-            <a:off x="6163056" y="1554480"/>
-            <a:ext cx="2679192" cy="3291840"/>
-          </a:xfrm>
-          <a:prstGeom prst="roundRect">
-            <a:avLst>
-              <a:gd name="adj" fmla="val 4500"/>
-            </a:avLst>
-          </a:prstGeom>
-          <a:solidFill>
-            <a:srgbClr val="F2F5F8"/>
-          </a:solidFill>
-          <a:ln w="12700">
-            <a:solidFill>
-              <a:srgbClr val="D4DCE4"/>
-            </a:solidFill>
-          </a:ln>
-          <a:effectLst/>
-        </p:spPr>
-        <p:style>
-          <a:lnRef idx="1">
-            <a:schemeClr val="accent1"/>
-          </a:lnRef>
-          <a:fillRef idx="3">
-            <a:schemeClr val="accent1"/>
-          </a:fillRef>
-          <a:effectRef idx="2">
-            <a:schemeClr val="accent1"/>
-          </a:effectRef>
-          <a:fontRef idx="minor">
-            <a:schemeClr val="lt1"/>
-          </a:fontRef>
-        </p:style>
-        <p:txBody>
-          <a:bodyPr rtlCol="0" anchor="t" wrap="square" lIns="164592" rIns="164592" tIns="164592" bIns="164592"/>
-          <a:lstStyle/>
-          <a:p>
-            <a:pPr algn="l">
-              <a:spcAft>
-                <a:spcPts val="300"/>
-              </a:spcAft>
-            </a:pPr>
-            <a:r>
-              <a:rPr sz="1050" b="1">
-                <a:solidFill>
-                  <a:srgbClr val="2E86AB"/>
-                </a:solidFill>
-                <a:latin typeface="Calibri"/>
-              </a:rPr>
-              <a:t>Phase 3  •  months 12–18</a:t>
-            </a:r>
-          </a:p>
-          <a:p>
-            <a:pPr algn="l">
-              <a:spcAft>
-                <a:spcPts val="1000"/>
-              </a:spcAft>
-            </a:pPr>
-            <a:r>
-              <a:rPr sz="1700" b="1">
-                <a:solidFill>
-                  <a:srgbClr val="0F2442"/>
-                </a:solidFill>
-                <a:latin typeface="Calibri"/>
-              </a:rPr>
-              <a:t>Proof</a:t>
-            </a:r>
-          </a:p>
-          <a:p>
-            <a:pPr algn="l">
-              <a:spcAft>
-                <a:spcPts val="700"/>
-              </a:spcAft>
-            </a:pPr>
-            <a:r>
-              <a:rPr sz="1150" b="0">
-                <a:solidFill>
-                  <a:srgbClr val="5B6676"/>
-                </a:solidFill>
-                <a:latin typeface="Calibri"/>
-              </a:rPr>
-              <a:t>•  Transformer support in compiler</a:t>
-            </a:r>
-          </a:p>
-          <a:p>
-            <a:pPr algn="l">
-              <a:spcAft>
-                <a:spcPts val="700"/>
-              </a:spcAft>
-            </a:pPr>
-            <a:r>
-              <a:rPr sz="1150" b="0">
-                <a:solidFill>
-                  <a:srgbClr val="5B6676"/>
-                </a:solidFill>
-                <a:latin typeface="Calibri"/>
-              </a:rPr>
-              <a:t>•  Flagship demo: two model families, one bitstream</a:t>
-            </a:r>
-          </a:p>
-          <a:p>
-            <a:pPr algn="l">
-              <a:spcAft>
-                <a:spcPts val="700"/>
-              </a:spcAft>
-            </a:pPr>
-            <a:r>
-              <a:rPr sz="1150" b="0">
-                <a:solidFill>
-                  <a:srgbClr val="5B6676"/>
-                </a:solidFill>
-                <a:latin typeface="Calibri"/>
-              </a:rPr>
-              <a:t>•  Publication + benchmark report</a:t>
-            </a:r>
-          </a:p>
-        </p:txBody>
-      </p:sp>
-      <p:sp>
-        <p:nvSpPr>
-          <p:cNvPr id="13" name="Rectangle 12"/>
-          <p:cNvSpPr/>
-          <p:nvPr/>
-        </p:nvSpPr>
-        <p:spPr>
-          <a:xfrm>
-            <a:off x="6163056" y="1554480"/>
-            <a:ext cx="2679192" cy="64008"/>
-          </a:xfrm>
-          <a:prstGeom prst="rect">
-            <a:avLst/>
-          </a:prstGeom>
-          <a:solidFill>
-            <a:srgbClr val="2E86AB"/>
-          </a:solidFill>
-          <a:ln>
-            <a:noFill/>
-          </a:ln>
-          <a:effectLst/>
-        </p:spPr>
-        <p:style>
-          <a:lnRef idx="1">
-            <a:schemeClr val="accent1"/>
-          </a:lnRef>
-          <a:fillRef idx="3">
-            <a:schemeClr val="accent1"/>
-          </a:fillRef>
-          <a:effectRef idx="2">
-            <a:schemeClr val="accent1"/>
-          </a:effectRef>
-          <a:fontRef idx="minor">
-            <a:schemeClr val="lt1"/>
-          </a:fontRef>
-        </p:style>
-        <p:txBody>
-          <a:bodyPr rtlCol="0" anchor="ctr"/>
-          <a:lstStyle/>
-          <a:p>
-            <a:pPr algn="ctr"/>
-          </a:p>
-        </p:txBody>
-      </p:sp>
-      <p:sp>
-        <p:nvSpPr>
-          <p:cNvPr id="14" name="Rounded Rectangle 13"/>
-          <p:cNvSpPr/>
-          <p:nvPr/>
-        </p:nvSpPr>
-        <p:spPr>
-          <a:xfrm>
-            <a:off x="8970264" y="1554480"/>
-            <a:ext cx="2679192" cy="3291840"/>
-          </a:xfrm>
-          <a:prstGeom prst="roundRect">
-            <a:avLst>
-              <a:gd name="adj" fmla="val 4500"/>
-            </a:avLst>
-          </a:prstGeom>
-          <a:solidFill>
-            <a:srgbClr val="F2F5F8"/>
-          </a:solidFill>
-          <a:ln w="12700">
-            <a:solidFill>
-              <a:srgbClr val="D4DCE4"/>
-            </a:solidFill>
-          </a:ln>
-          <a:effectLst/>
-        </p:spPr>
-        <p:style>
-          <a:lnRef idx="1">
-            <a:schemeClr val="accent1"/>
-          </a:lnRef>
-          <a:fillRef idx="3">
-            <a:schemeClr val="accent1"/>
-          </a:fillRef>
-          <a:effectRef idx="2">
-            <a:schemeClr val="accent1"/>
-          </a:effectRef>
-          <a:fontRef idx="minor">
-            <a:schemeClr val="lt1"/>
-          </a:fontRef>
-        </p:style>
-        <p:txBody>
-          <a:bodyPr rtlCol="0" anchor="t" wrap="square" lIns="164592" rIns="164592" tIns="164592" bIns="164592"/>
-          <a:lstStyle/>
-          <a:p>
-            <a:pPr algn="l">
-              <a:spcAft>
-                <a:spcPts val="300"/>
-              </a:spcAft>
-            </a:pPr>
-            <a:r>
-              <a:rPr sz="1050" b="1">
-                <a:solidFill>
-                  <a:srgbClr val="2E86AB"/>
-                </a:solidFill>
-                <a:latin typeface="Calibri"/>
-              </a:rPr>
-              <a:t>Phase 4  •  months 18–24</a:t>
-            </a:r>
-          </a:p>
-          <a:p>
-            <a:pPr algn="l">
-              <a:spcAft>
-                <a:spcPts val="1000"/>
-              </a:spcAft>
-            </a:pPr>
-            <a:r>
-              <a:rPr sz="1700" b="1">
-                <a:solidFill>
-                  <a:srgbClr val="0F2442"/>
-                </a:solidFill>
-                <a:latin typeface="Calibri"/>
-              </a:rPr>
-              <a:t>Product</a:t>
-            </a:r>
-          </a:p>
-          <a:p>
-            <a:pPr algn="l">
-              <a:spcAft>
-                <a:spcPts val="700"/>
-              </a:spcAft>
-            </a:pPr>
-            <a:r>
-              <a:rPr sz="1150" b="0">
-                <a:solidFill>
-                  <a:srgbClr val="5B6676"/>
-                </a:solidFill>
-                <a:latin typeface="Calibri"/>
-              </a:rPr>
-              <a:t>•  ASIC hardening + PPA characterization</a:t>
-            </a:r>
-          </a:p>
-          <a:p>
-            <a:pPr algn="l">
-              <a:spcAft>
-                <a:spcPts val="700"/>
-              </a:spcAft>
-            </a:pPr>
-            <a:r>
-              <a:rPr sz="1150" b="0">
-                <a:solidFill>
-                  <a:srgbClr val="5B6676"/>
-                </a:solidFill>
-                <a:latin typeface="Calibri"/>
-              </a:rPr>
-              <a:t>•  Design-time configurator (tile-mix tool)</a:t>
-            </a:r>
-          </a:p>
-          <a:p>
-            <a:pPr algn="l">
-              <a:spcAft>
-                <a:spcPts val="700"/>
-              </a:spcAft>
-            </a:pPr>
-            <a:r>
-              <a:rPr sz="1150" b="0">
-                <a:solidFill>
-                  <a:srgbClr val="5B6676"/>
-                </a:solidFill>
-                <a:latin typeface="Calibri"/>
-              </a:rPr>
-              <a:t>•  First evaluation licenses signed</a:t>
-            </a:r>
-          </a:p>
-        </p:txBody>
-      </p:sp>
-      <p:sp>
-        <p:nvSpPr>
-          <p:cNvPr id="15" name="Rectangle 14"/>
-          <p:cNvSpPr/>
-          <p:nvPr/>
-        </p:nvSpPr>
-        <p:spPr>
-          <a:xfrm>
-            <a:off x="8970264" y="1554480"/>
-            <a:ext cx="2679192" cy="64008"/>
-          </a:xfrm>
-          <a:prstGeom prst="rect">
-            <a:avLst/>
-          </a:prstGeom>
-          <a:solidFill>
-            <a:srgbClr val="2E86AB"/>
-          </a:solidFill>
-          <a:ln>
-            <a:noFill/>
-          </a:ln>
-          <a:effectLst/>
-        </p:spPr>
-        <p:style>
-          <a:lnRef idx="1">
-            <a:schemeClr val="accent1"/>
-          </a:lnRef>
-          <a:fillRef idx="3">
-            <a:schemeClr val="accent1"/>
-          </a:fillRef>
-          <a:effectRef idx="2">
-            <a:schemeClr val="accent1"/>
-          </a:effectRef>
-          <a:fontRef idx="minor">
-            <a:schemeClr val="lt1"/>
-          </a:fontRef>
-        </p:style>
-        <p:txBody>
-          <a:bodyPr rtlCol="0" anchor="ctr"/>
-          <a:lstStyle/>
-          <a:p>
-            <a:pPr algn="ctr"/>
-          </a:p>
-        </p:txBody>
-      </p:sp>
-      <p:sp>
-        <p:nvSpPr>
-          <p:cNvPr id="16" name="TextBox 15"/>
+      <p:graphicFrame>
+        <p:nvGraphicFramePr>
+          <p:cNvPr id="8" name="Table 7"/>
+          <p:cNvGraphicFramePr>
+            <a:graphicFrameLocks noGrp="1"/>
+          </p:cNvGraphicFramePr>
+          <p:nvPr/>
+        </p:nvGraphicFramePr>
+        <p:xfrm>
+          <a:off x="548640" y="1417320"/>
+          <a:ext cx="11091670" cy="4425696"/>
+        </p:xfrm>
+        <a:graphic>
+          <a:graphicData uri="http://schemas.openxmlformats.org/drawingml/2006/table">
+            <a:tbl>
+              <a:tblPr firstRow="1" bandRow="1">
+                <a:tableStyleId>{5C22544A-7EE6-4342-B048-85BDC9FD1C3A}</a:tableStyleId>
+              </a:tblPr>
+              <a:tblGrid>
+                <a:gridCol w="2440167"/>
+                <a:gridCol w="4880335"/>
+                <a:gridCol w="1109167"/>
+                <a:gridCol w="2662001"/>
+              </a:tblGrid>
+              <a:tr h="329184">
+                <a:tc>
+                  <a:txBody>
+                    <a:bodyPr/>
+                    <a:lstStyle/>
+                    <a:p>
+                      <a:r>
+                        <a:rPr sz="1100" b="1">
+                          <a:solidFill>
+                            <a:srgbClr val="FFFFFF"/>
+                          </a:solidFill>
+                          <a:latin typeface="Calibri"/>
+                        </a:rPr>
+                        <a:t>Stream</a:t>
+                      </a:r>
+                    </a:p>
+                  </a:txBody>
+                  <a:tcPr marL="73152" marR="54864" marT="27432" marB="27432" anchor="ctr">
+                    <a:solidFill>
+                      <a:srgbClr val="0F2442"/>
+                    </a:solidFill>
+                  </a:tcPr>
+                </a:tc>
+                <a:tc>
+                  <a:txBody>
+                    <a:bodyPr/>
+                    <a:lstStyle/>
+                    <a:p>
+                      <a:r>
+                        <a:rPr sz="1100" b="1">
+                          <a:solidFill>
+                            <a:srgbClr val="FFFFFF"/>
+                          </a:solidFill>
+                          <a:latin typeface="Calibri"/>
+                        </a:rPr>
+                        <a:t>What it is</a:t>
+                      </a:r>
+                    </a:p>
+                  </a:txBody>
+                  <a:tcPr marL="73152" marR="54864" marT="27432" marB="27432" anchor="ctr">
+                    <a:solidFill>
+                      <a:srgbClr val="0F2442"/>
+                    </a:solidFill>
+                  </a:tcPr>
+                </a:tc>
+                <a:tc>
+                  <a:txBody>
+                    <a:bodyPr/>
+                    <a:lstStyle/>
+                    <a:p>
+                      <a:r>
+                        <a:rPr sz="1100" b="1">
+                          <a:solidFill>
+                            <a:srgbClr val="FFFFFF"/>
+                          </a:solidFill>
+                          <a:latin typeface="Calibri"/>
+                        </a:rPr>
+                        <a:t>Starts</a:t>
+                      </a:r>
+                    </a:p>
+                  </a:txBody>
+                  <a:tcPr marL="73152" marR="54864" marT="27432" marB="27432" anchor="ctr">
+                    <a:solidFill>
+                      <a:srgbClr val="0F2442"/>
+                    </a:solidFill>
+                  </a:tcPr>
+                </a:tc>
+                <a:tc>
+                  <a:txBody>
+                    <a:bodyPr/>
+                    <a:lstStyle/>
+                    <a:p>
+                      <a:r>
+                        <a:rPr sz="1100" b="1">
+                          <a:solidFill>
+                            <a:srgbClr val="FFFFFF"/>
+                          </a:solidFill>
+                          <a:latin typeface="Calibri"/>
+                        </a:rPr>
+                        <a:t>Character</a:t>
+                      </a:r>
+                    </a:p>
+                  </a:txBody>
+                  <a:tcPr marL="73152" marR="54864" marT="27432" marB="27432" anchor="ctr">
+                    <a:solidFill>
+                      <a:srgbClr val="0F2442"/>
+                    </a:solidFill>
+                  </a:tcPr>
+                </a:tc>
+              </a:tr>
+              <a:tr h="512064">
+                <a:tc>
+                  <a:txBody>
+                    <a:bodyPr/>
+                    <a:lstStyle/>
+                    <a:p>
+                      <a:r>
+                        <a:rPr sz="1050" b="1">
+                          <a:solidFill>
+                            <a:srgbClr val="0F2442"/>
+                          </a:solidFill>
+                          <a:latin typeface="Calibri"/>
+                        </a:rPr>
+                        <a:t>FPGA edge modules &amp; dev kits</a:t>
+                      </a:r>
+                    </a:p>
+                  </a:txBody>
+                  <a:tcPr marL="73152" marR="54864" marT="27432" marB="27432" anchor="ctr">
+                    <a:solidFill>
+                      <a:srgbClr val="FFFFFF"/>
+                    </a:solidFill>
+                  </a:tcPr>
+                </a:tc>
+                <a:tc>
+                  <a:txBody>
+                    <a:bodyPr/>
+                    <a:lstStyle/>
+                    <a:p>
+                      <a:r>
+                        <a:rPr sz="1050" b="0">
+                          <a:solidFill>
+                            <a:srgbClr val="1F2937"/>
+                          </a:solidFill>
+                          <a:latin typeface="Calibri"/>
+                        </a:rPr>
+                        <a:t>M.2 / PCIe / SoM accelerator cards for frozen-model verticals (medical, industrial, radar) — sold before any ASIC exists</a:t>
+                      </a:r>
+                    </a:p>
+                  </a:txBody>
+                  <a:tcPr marL="73152" marR="54864" marT="27432" marB="27432" anchor="ctr">
+                    <a:solidFill>
+                      <a:srgbClr val="FFFFFF"/>
+                    </a:solidFill>
+                  </a:tcPr>
+                </a:tc>
+                <a:tc>
+                  <a:txBody>
+                    <a:bodyPr/>
+                    <a:lstStyle/>
+                    <a:p>
+                      <a:r>
+                        <a:rPr sz="1050" b="0">
+                          <a:solidFill>
+                            <a:srgbClr val="1F2937"/>
+                          </a:solidFill>
+                          <a:latin typeface="Calibri"/>
+                        </a:rPr>
+                        <a:t>Year 1</a:t>
+                      </a:r>
+                    </a:p>
+                  </a:txBody>
+                  <a:tcPr marL="73152" marR="54864" marT="27432" marB="27432" anchor="ctr">
+                    <a:solidFill>
+                      <a:srgbClr val="FFFFFF"/>
+                    </a:solidFill>
+                  </a:tcPr>
+                </a:tc>
+                <a:tc>
+                  <a:txBody>
+                    <a:bodyPr/>
+                    <a:lstStyle/>
+                    <a:p>
+                      <a:r>
+                        <a:rPr sz="1050" b="0">
+                          <a:solidFill>
+                            <a:srgbClr val="1F2937"/>
+                          </a:solidFill>
+                          <a:latin typeface="Calibri"/>
+                        </a:rPr>
+                        <a:t>Early product cash</a:t>
+                      </a:r>
+                    </a:p>
+                  </a:txBody>
+                  <a:tcPr marL="73152" marR="54864" marT="27432" marB="27432" anchor="ctr">
+                    <a:solidFill>
+                      <a:srgbClr val="FFFFFF"/>
+                    </a:solidFill>
+                  </a:tcPr>
+                </a:tc>
+              </a:tr>
+              <a:tr h="512064">
+                <a:tc>
+                  <a:txBody>
+                    <a:bodyPr/>
+                    <a:lstStyle/>
+                    <a:p>
+                      <a:r>
+                        <a:rPr sz="1050" b="1">
+                          <a:solidFill>
+                            <a:srgbClr val="0F2442"/>
+                          </a:solidFill>
+                          <a:latin typeface="Calibri"/>
+                        </a:rPr>
+                        <a:t>Model porting services</a:t>
+                      </a:r>
+                    </a:p>
+                  </a:txBody>
+                  <a:tcPr marL="73152" marR="54864" marT="27432" marB="27432" anchor="ctr">
+                    <a:solidFill>
+                      <a:srgbClr val="F2F5F8"/>
+                    </a:solidFill>
+                  </a:tcPr>
+                </a:tc>
+                <a:tc>
+                  <a:txBody>
+                    <a:bodyPr/>
+                    <a:lstStyle/>
+                    <a:p>
+                      <a:r>
+                        <a:rPr sz="1050" b="0">
+                          <a:solidFill>
+                            <a:srgbClr val="1F2937"/>
+                          </a:solidFill>
+                          <a:latin typeface="Calibri"/>
+                        </a:rPr>
+                        <a:t>Paid optimization of customer models onto RIA</a:t>
+                      </a:r>
+                    </a:p>
+                  </a:txBody>
+                  <a:tcPr marL="73152" marR="54864" marT="27432" marB="27432" anchor="ctr">
+                    <a:solidFill>
+                      <a:srgbClr val="F2F5F8"/>
+                    </a:solidFill>
+                  </a:tcPr>
+                </a:tc>
+                <a:tc>
+                  <a:txBody>
+                    <a:bodyPr/>
+                    <a:lstStyle/>
+                    <a:p>
+                      <a:r>
+                        <a:rPr sz="1050" b="0">
+                          <a:solidFill>
+                            <a:srgbClr val="1F2937"/>
+                          </a:solidFill>
+                          <a:latin typeface="Calibri"/>
+                        </a:rPr>
+                        <a:t>Year 1</a:t>
+                      </a:r>
+                    </a:p>
+                  </a:txBody>
+                  <a:tcPr marL="73152" marR="54864" marT="27432" marB="27432" anchor="ctr">
+                    <a:solidFill>
+                      <a:srgbClr val="F2F5F8"/>
+                    </a:solidFill>
+                  </a:tcPr>
+                </a:tc>
+                <a:tc>
+                  <a:txBody>
+                    <a:bodyPr/>
+                    <a:lstStyle/>
+                    <a:p>
+                      <a:r>
+                        <a:rPr sz="1050" b="0">
+                          <a:solidFill>
+                            <a:srgbClr val="1F2937"/>
+                          </a:solidFill>
+                          <a:latin typeface="Calibri"/>
+                        </a:rPr>
+                        <a:t>Services — capped by policy</a:t>
+                      </a:r>
+                    </a:p>
+                  </a:txBody>
+                  <a:tcPr marL="73152" marR="54864" marT="27432" marB="27432" anchor="ctr">
+                    <a:solidFill>
+                      <a:srgbClr val="F2F5F8"/>
+                    </a:solidFill>
+                  </a:tcPr>
+                </a:tc>
+              </a:tr>
+              <a:tr h="512064">
+                <a:tc>
+                  <a:txBody>
+                    <a:bodyPr/>
+                    <a:lstStyle/>
+                    <a:p>
+                      <a:r>
+                        <a:rPr sz="1050" b="1">
+                          <a:solidFill>
+                            <a:srgbClr val="0F2442"/>
+                          </a:solidFill>
+                          <a:latin typeface="Calibri"/>
+                        </a:rPr>
+                        <a:t>Non-dilutive funding</a:t>
+                      </a:r>
+                    </a:p>
+                  </a:txBody>
+                  <a:tcPr marL="73152" marR="54864" marT="27432" marB="27432" anchor="ctr">
+                    <a:solidFill>
+                      <a:srgbClr val="FFFFFF"/>
+                    </a:solidFill>
+                  </a:tcPr>
+                </a:tc>
+                <a:tc>
+                  <a:txBody>
+                    <a:bodyPr/>
+                    <a:lstStyle/>
+                    <a:p>
+                      <a:r>
+                        <a:rPr sz="1050" b="0">
+                          <a:solidFill>
+                            <a:srgbClr val="1F2937"/>
+                          </a:solidFill>
+                          <a:latin typeface="Calibri"/>
+                        </a:rPr>
+                        <a:t>DLI / India Semiconductor Mission grants, funded R&amp;D</a:t>
+                      </a:r>
+                    </a:p>
+                  </a:txBody>
+                  <a:tcPr marL="73152" marR="54864" marT="27432" marB="27432" anchor="ctr">
+                    <a:solidFill>
+                      <a:srgbClr val="FFFFFF"/>
+                    </a:solidFill>
+                  </a:tcPr>
+                </a:tc>
+                <a:tc>
+                  <a:txBody>
+                    <a:bodyPr/>
+                    <a:lstStyle/>
+                    <a:p>
+                      <a:r>
+                        <a:rPr sz="1050" b="0">
+                          <a:solidFill>
+                            <a:srgbClr val="1F2937"/>
+                          </a:solidFill>
+                          <a:latin typeface="Calibri"/>
+                        </a:rPr>
+                        <a:t>Year 0</a:t>
+                      </a:r>
+                    </a:p>
+                  </a:txBody>
+                  <a:tcPr marL="73152" marR="54864" marT="27432" marB="27432" anchor="ctr">
+                    <a:solidFill>
+                      <a:srgbClr val="FFFFFF"/>
+                    </a:solidFill>
+                  </a:tcPr>
+                </a:tc>
+                <a:tc>
+                  <a:txBody>
+                    <a:bodyPr/>
+                    <a:lstStyle/>
+                    <a:p>
+                      <a:r>
+                        <a:rPr sz="1050" b="0">
+                          <a:solidFill>
+                            <a:srgbClr val="1F2937"/>
+                          </a:solidFill>
+                          <a:latin typeface="Calibri"/>
+                        </a:rPr>
+                        <a:t>Cash without equity</a:t>
+                      </a:r>
+                    </a:p>
+                  </a:txBody>
+                  <a:tcPr marL="73152" marR="54864" marT="27432" marB="27432" anchor="ctr">
+                    <a:solidFill>
+                      <a:srgbClr val="FFFFFF"/>
+                    </a:solidFill>
+                  </a:tcPr>
+                </a:tc>
+              </a:tr>
+              <a:tr h="512064">
+                <a:tc>
+                  <a:txBody>
+                    <a:bodyPr/>
+                    <a:lstStyle/>
+                    <a:p>
+                      <a:r>
+                        <a:rPr sz="1050" b="1">
+                          <a:solidFill>
+                            <a:srgbClr val="0F2442"/>
+                          </a:solidFill>
+                          <a:latin typeface="Calibri"/>
+                        </a:rPr>
+                        <a:t>Integration NRE</a:t>
+                      </a:r>
+                    </a:p>
+                  </a:txBody>
+                  <a:tcPr marL="73152" marR="54864" marT="27432" marB="27432" anchor="ctr">
+                    <a:solidFill>
+                      <a:srgbClr val="F2F5F8"/>
+                    </a:solidFill>
+                  </a:tcPr>
+                </a:tc>
+                <a:tc>
+                  <a:txBody>
+                    <a:bodyPr/>
+                    <a:lstStyle/>
+                    <a:p>
+                      <a:r>
+                        <a:rPr sz="1050" b="0">
+                          <a:solidFill>
+                            <a:srgbClr val="1F2937"/>
+                          </a:solidFill>
+                          <a:latin typeface="Calibri"/>
+                        </a:rPr>
+                        <a:t>Customer-specific tile-mix configuration + integration support</a:t>
+                      </a:r>
+                    </a:p>
+                  </a:txBody>
+                  <a:tcPr marL="73152" marR="54864" marT="27432" marB="27432" anchor="ctr">
+                    <a:solidFill>
+                      <a:srgbClr val="F2F5F8"/>
+                    </a:solidFill>
+                  </a:tcPr>
+                </a:tc>
+                <a:tc>
+                  <a:txBody>
+                    <a:bodyPr/>
+                    <a:lstStyle/>
+                    <a:p>
+                      <a:r>
+                        <a:rPr sz="1050" b="0">
+                          <a:solidFill>
+                            <a:srgbClr val="1F2937"/>
+                          </a:solidFill>
+                          <a:latin typeface="Calibri"/>
+                        </a:rPr>
+                        <a:t>Year 2</a:t>
+                      </a:r>
+                    </a:p>
+                  </a:txBody>
+                  <a:tcPr marL="73152" marR="54864" marT="27432" marB="27432" anchor="ctr">
+                    <a:solidFill>
+                      <a:srgbClr val="F2F5F8"/>
+                    </a:solidFill>
+                  </a:tcPr>
+                </a:tc>
+                <a:tc>
+                  <a:txBody>
+                    <a:bodyPr/>
+                    <a:lstStyle/>
+                    <a:p>
+                      <a:r>
+                        <a:rPr sz="1050" b="0">
+                          <a:solidFill>
+                            <a:srgbClr val="1F2937"/>
+                          </a:solidFill>
+                          <a:latin typeface="Calibri"/>
+                        </a:rPr>
+                        <a:t>Per engagement</a:t>
+                      </a:r>
+                    </a:p>
+                  </a:txBody>
+                  <a:tcPr marL="73152" marR="54864" marT="27432" marB="27432" anchor="ctr">
+                    <a:solidFill>
+                      <a:srgbClr val="F2F5F8"/>
+                    </a:solidFill>
+                  </a:tcPr>
+                </a:tc>
+              </a:tr>
+              <a:tr h="512064">
+                <a:tc>
+                  <a:txBody>
+                    <a:bodyPr/>
+                    <a:lstStyle/>
+                    <a:p>
+                      <a:r>
+                        <a:rPr sz="1050" b="1">
+                          <a:solidFill>
+                            <a:srgbClr val="0F2442"/>
+                          </a:solidFill>
+                          <a:latin typeface="Calibri"/>
+                        </a:rPr>
+                        <a:t>Compiler &amp; tools subscription</a:t>
+                      </a:r>
+                    </a:p>
+                  </a:txBody>
+                  <a:tcPr marL="73152" marR="54864" marT="27432" marB="27432" anchor="ctr">
+                    <a:solidFill>
+                      <a:srgbClr val="FFFFFF"/>
+                    </a:solidFill>
+                  </a:tcPr>
+                </a:tc>
+                <a:tc>
+                  <a:txBody>
+                    <a:bodyPr/>
+                    <a:lstStyle/>
+                    <a:p>
+                      <a:r>
+                        <a:rPr sz="1050" b="0">
+                          <a:solidFill>
+                            <a:srgbClr val="1F2937"/>
+                          </a:solidFill>
+                          <a:latin typeface="Calibri"/>
+                        </a:rPr>
+                        <a:t>Annual license; scheduling gains ship to every licensee</a:t>
+                      </a:r>
+                    </a:p>
+                  </a:txBody>
+                  <a:tcPr marL="73152" marR="54864" marT="27432" marB="27432" anchor="ctr">
+                    <a:solidFill>
+                      <a:srgbClr val="FFFFFF"/>
+                    </a:solidFill>
+                  </a:tcPr>
+                </a:tc>
+                <a:tc>
+                  <a:txBody>
+                    <a:bodyPr/>
+                    <a:lstStyle/>
+                    <a:p>
+                      <a:r>
+                        <a:rPr sz="1050" b="0">
+                          <a:solidFill>
+                            <a:srgbClr val="1F2937"/>
+                          </a:solidFill>
+                          <a:latin typeface="Calibri"/>
+                        </a:rPr>
+                        <a:t>Year 2</a:t>
+                      </a:r>
+                    </a:p>
+                  </a:txBody>
+                  <a:tcPr marL="73152" marR="54864" marT="27432" marB="27432" anchor="ctr">
+                    <a:solidFill>
+                      <a:srgbClr val="FFFFFF"/>
+                    </a:solidFill>
+                  </a:tcPr>
+                </a:tc>
+                <a:tc>
+                  <a:txBody>
+                    <a:bodyPr/>
+                    <a:lstStyle/>
+                    <a:p>
+                      <a:r>
+                        <a:rPr sz="1050" b="0">
+                          <a:solidFill>
+                            <a:srgbClr val="1F2937"/>
+                          </a:solidFill>
+                          <a:latin typeface="Calibri"/>
+                        </a:rPr>
+                        <a:t>Recurring — the gem</a:t>
+                      </a:r>
+                    </a:p>
+                  </a:txBody>
+                  <a:tcPr marL="73152" marR="54864" marT="27432" marB="27432" anchor="ctr">
+                    <a:solidFill>
+                      <a:srgbClr val="FFFFFF"/>
+                    </a:solidFill>
+                  </a:tcPr>
+                </a:tc>
+              </a:tr>
+              <a:tr h="512064">
+                <a:tc>
+                  <a:txBody>
+                    <a:bodyPr/>
+                    <a:lstStyle/>
+                    <a:p>
+                      <a:r>
+                        <a:rPr sz="1050" b="1">
+                          <a:solidFill>
+                            <a:srgbClr val="0F2442"/>
+                          </a:solidFill>
+                          <a:latin typeface="Calibri"/>
+                        </a:rPr>
+                        <a:t>IP license fees</a:t>
+                      </a:r>
+                    </a:p>
+                  </a:txBody>
+                  <a:tcPr marL="73152" marR="54864" marT="27432" marB="27432" anchor="ctr">
+                    <a:solidFill>
+                      <a:srgbClr val="F2F5F8"/>
+                    </a:solidFill>
+                  </a:tcPr>
+                </a:tc>
+                <a:tc>
+                  <a:txBody>
+                    <a:bodyPr/>
+                    <a:lstStyle/>
+                    <a:p>
+                      <a:r>
+                        <a:rPr sz="1050" b="0">
+                          <a:solidFill>
+                            <a:srgbClr val="1F2937"/>
+                          </a:solidFill>
+                          <a:latin typeface="Calibri"/>
+                        </a:rPr>
+                        <a:t>Upfront fee per design win for tile/fabric RTL + compiler</a:t>
+                      </a:r>
+                    </a:p>
+                  </a:txBody>
+                  <a:tcPr marL="73152" marR="54864" marT="27432" marB="27432" anchor="ctr">
+                    <a:solidFill>
+                      <a:srgbClr val="F2F5F8"/>
+                    </a:solidFill>
+                  </a:tcPr>
+                </a:tc>
+                <a:tc>
+                  <a:txBody>
+                    <a:bodyPr/>
+                    <a:lstStyle/>
+                    <a:p>
+                      <a:r>
+                        <a:rPr sz="1050" b="0">
+                          <a:solidFill>
+                            <a:srgbClr val="1F2937"/>
+                          </a:solidFill>
+                          <a:latin typeface="Calibri"/>
+                        </a:rPr>
+                        <a:t>Year 2–3</a:t>
+                      </a:r>
+                    </a:p>
+                  </a:txBody>
+                  <a:tcPr marL="73152" marR="54864" marT="27432" marB="27432" anchor="ctr">
+                    <a:solidFill>
+                      <a:srgbClr val="F2F5F8"/>
+                    </a:solidFill>
+                  </a:tcPr>
+                </a:tc>
+                <a:tc>
+                  <a:txBody>
+                    <a:bodyPr/>
+                    <a:lstStyle/>
+                    <a:p>
+                      <a:r>
+                        <a:rPr sz="1050" b="0">
+                          <a:solidFill>
+                            <a:srgbClr val="1F2937"/>
+                          </a:solidFill>
+                          <a:latin typeface="Calibri"/>
+                        </a:rPr>
+                        <a:t>Lumpy, one-time</a:t>
+                      </a:r>
+                    </a:p>
+                  </a:txBody>
+                  <a:tcPr marL="73152" marR="54864" marT="27432" marB="27432" anchor="ctr">
+                    <a:solidFill>
+                      <a:srgbClr val="F2F5F8"/>
+                    </a:solidFill>
+                  </a:tcPr>
+                </a:tc>
+              </a:tr>
+              <a:tr h="512064">
+                <a:tc>
+                  <a:txBody>
+                    <a:bodyPr/>
+                    <a:lstStyle/>
+                    <a:p>
+                      <a:r>
+                        <a:rPr sz="1050" b="1">
+                          <a:solidFill>
+                            <a:srgbClr val="0F2442"/>
+                          </a:solidFill>
+                          <a:latin typeface="Calibri"/>
+                        </a:rPr>
+                        <a:t>Per-unit royalties</a:t>
+                      </a:r>
+                    </a:p>
+                  </a:txBody>
+                  <a:tcPr marL="73152" marR="54864" marT="27432" marB="27432" anchor="ctr">
+                    <a:solidFill>
+                      <a:srgbClr val="FFFFFF"/>
+                    </a:solidFill>
+                  </a:tcPr>
+                </a:tc>
+                <a:tc>
+                  <a:txBody>
+                    <a:bodyPr/>
+                    <a:lstStyle/>
+                    <a:p>
+                      <a:r>
+                        <a:rPr sz="1050" b="0">
+                          <a:solidFill>
+                            <a:srgbClr val="1F2937"/>
+                          </a:solidFill>
+                          <a:latin typeface="Calibri"/>
+                        </a:rPr>
+                        <a:t>Fee on every customer SoC shipped with RIA inside</a:t>
+                      </a:r>
+                    </a:p>
+                  </a:txBody>
+                  <a:tcPr marL="73152" marR="54864" marT="27432" marB="27432" anchor="ctr">
+                    <a:solidFill>
+                      <a:srgbClr val="FFFFFF"/>
+                    </a:solidFill>
+                  </a:tcPr>
+                </a:tc>
+                <a:tc>
+                  <a:txBody>
+                    <a:bodyPr/>
+                    <a:lstStyle/>
+                    <a:p>
+                      <a:r>
+                        <a:rPr sz="1050" b="0">
+                          <a:solidFill>
+                            <a:srgbClr val="1F2937"/>
+                          </a:solidFill>
+                          <a:latin typeface="Calibri"/>
+                        </a:rPr>
+                        <a:t>Year 3–4</a:t>
+                      </a:r>
+                    </a:p>
+                  </a:txBody>
+                  <a:tcPr marL="73152" marR="54864" marT="27432" marB="27432" anchor="ctr">
+                    <a:solidFill>
+                      <a:srgbClr val="FFFFFF"/>
+                    </a:solidFill>
+                  </a:tcPr>
+                </a:tc>
+                <a:tc>
+                  <a:txBody>
+                    <a:bodyPr/>
+                    <a:lstStyle/>
+                    <a:p>
+                      <a:r>
+                        <a:rPr sz="1050" b="0">
+                          <a:solidFill>
+                            <a:srgbClr val="1F2937"/>
+                          </a:solidFill>
+                          <a:latin typeface="Calibri"/>
+                        </a:rPr>
+                        <a:t>Compounding, high margin</a:t>
+                      </a:r>
+                    </a:p>
+                  </a:txBody>
+                  <a:tcPr marL="73152" marR="54864" marT="27432" marB="27432" anchor="ctr">
+                    <a:solidFill>
+                      <a:srgbClr val="FFFFFF"/>
+                    </a:solidFill>
+                  </a:tcPr>
+                </a:tc>
+              </a:tr>
+              <a:tr h="512064">
+                <a:tc>
+                  <a:txBody>
+                    <a:bodyPr/>
+                    <a:lstStyle/>
+                    <a:p>
+                      <a:r>
+                        <a:rPr sz="1050" b="1">
+                          <a:solidFill>
+                            <a:srgbClr val="0F2442"/>
+                          </a:solidFill>
+                          <a:latin typeface="Calibri"/>
+                        </a:rPr>
+                        <a:t>Hardened chiplet (future)</a:t>
+                      </a:r>
+                    </a:p>
+                  </a:txBody>
+                  <a:tcPr marL="73152" marR="54864" marT="27432" marB="27432" anchor="ctr">
+                    <a:solidFill>
+                      <a:srgbClr val="F2F5F8"/>
+                    </a:solidFill>
+                  </a:tcPr>
+                </a:tc>
+                <a:tc>
+                  <a:txBody>
+                    <a:bodyPr/>
+                    <a:lstStyle/>
+                    <a:p>
+                      <a:r>
+                        <a:rPr sz="1050" b="0">
+                          <a:solidFill>
+                            <a:srgbClr val="1F2937"/>
+                          </a:solidFill>
+                          <a:latin typeface="Calibri"/>
+                        </a:rPr>
+                        <a:t>RIA as a UCIe chiplet SoC vendors drop in — a tier above RTL licensing</a:t>
+                      </a:r>
+                    </a:p>
+                  </a:txBody>
+                  <a:tcPr marL="73152" marR="54864" marT="27432" marB="27432" anchor="ctr">
+                    <a:solidFill>
+                      <a:srgbClr val="F2F5F8"/>
+                    </a:solidFill>
+                  </a:tcPr>
+                </a:tc>
+                <a:tc>
+                  <a:txBody>
+                    <a:bodyPr/>
+                    <a:lstStyle/>
+                    <a:p>
+                      <a:r>
+                        <a:rPr sz="1050" b="0">
+                          <a:solidFill>
+                            <a:srgbClr val="1F2937"/>
+                          </a:solidFill>
+                          <a:latin typeface="Calibri"/>
+                        </a:rPr>
+                        <a:t>Year 4+</a:t>
+                      </a:r>
+                    </a:p>
+                  </a:txBody>
+                  <a:tcPr marL="73152" marR="54864" marT="27432" marB="27432" anchor="ctr">
+                    <a:solidFill>
+                      <a:srgbClr val="F2F5F8"/>
+                    </a:solidFill>
+                  </a:tcPr>
+                </a:tc>
+                <a:tc>
+                  <a:txBody>
+                    <a:bodyPr/>
+                    <a:lstStyle/>
+                    <a:p>
+                      <a:r>
+                        <a:rPr sz="1050" b="0">
+                          <a:solidFill>
+                            <a:srgbClr val="1F2937"/>
+                          </a:solidFill>
+                          <a:latin typeface="Calibri"/>
+                        </a:rPr>
+                        <a:t>Optional expansion</a:t>
+                      </a:r>
+                    </a:p>
+                  </a:txBody>
+                  <a:tcPr marL="73152" marR="54864" marT="27432" marB="27432" anchor="ctr">
+                    <a:solidFill>
+                      <a:srgbClr val="F2F5F8"/>
+                    </a:solidFill>
+                  </a:tcPr>
+                </a:tc>
+              </a:tr>
+            </a:tbl>
+          </a:graphicData>
+        </a:graphic>
+      </p:graphicFrame>
+      <p:sp>
+        <p:nvSpPr>
+          <p:cNvPr id="9" name="TextBox 8"/>
           <p:cNvSpPr txBox="1"/>
           <p:nvPr/>
         </p:nvSpPr>
         <p:spPr>
           <a:xfrm>
-            <a:off x="548640" y="5120640"/>
+            <a:off x="548640" y="5897880"/>
             <a:ext cx="11064240" cy="457200"/>
           </a:xfrm>
           <a:prstGeom prst="rect">
@@ -7235,13 +7399,13 @@
               </a:spcAft>
             </a:pPr>
             <a:r>
-              <a:rPr sz="1350" b="1">
-                <a:solidFill>
-                  <a:srgbClr val="0F2442"/>
-                </a:solidFill>
-                <a:latin typeface="Calibri"/>
-              </a:rPr>
-              <a:t>Exit criterion for each phase is a measured number on hardware — not a document.</a:t>
+              <a:rPr sz="1300" b="1">
+                <a:solidFill>
+                  <a:srgbClr val="2E86AB"/>
+                </a:solidFill>
+                <a:latin typeface="Calibri"/>
+              </a:rPr>
+              <a:t>Every early stream doubles as pipeline: dev-kit buyers and porting clients are tomorrow's licensees.</a:t>
             </a:r>
           </a:p>
         </p:txBody>
@@ -7342,7 +7506,7 @@
                 </a:solidFill>
                 <a:latin typeface="Calibri"/>
               </a:rPr>
-              <a:t>HONESTY</a:t>
+              <a:t>BUSINESS</a:t>
             </a:r>
           </a:p>
         </p:txBody>
@@ -7381,7 +7545,7 @@
                 </a:solidFill>
                 <a:latin typeface="Calibri"/>
               </a:rPr>
-              <a:t>Risks — stated, owned, and instrumented</a:t>
+              <a:t>Revenue phasing — and the discipline it demands</a:t>
             </a:r>
           </a:p>
         </p:txBody>
@@ -7465,6 +7629,1877 @@
                 <a:latin typeface="Calibri"/>
               </a:rPr>
               <a:t>15</a:t>
+            </a:r>
+          </a:p>
+        </p:txBody>
+      </p:sp>
+      <p:sp>
+        <p:nvSpPr>
+          <p:cNvPr id="7" name="TextBox 6"/>
+          <p:cNvSpPr txBox="1"/>
+          <p:nvPr/>
+        </p:nvSpPr>
+        <p:spPr>
+          <a:xfrm>
+            <a:off x="548640" y="6473952"/>
+            <a:ext cx="5486400" cy="274320"/>
+          </a:xfrm>
+          <a:prstGeom prst="rect">
+            <a:avLst/>
+          </a:prstGeom>
+          <a:noFill/>
+        </p:spPr>
+        <p:txBody>
+          <a:bodyPr wrap="square" anchor="t" lIns="18288" rIns="18288" tIns="18288" bIns="18288">
+            <a:spAutoFit/>
+          </a:bodyPr>
+          <a:lstStyle/>
+          <a:p>
+            <a:pPr algn="l">
+              <a:spcAft>
+                <a:spcPts val="0"/>
+              </a:spcAft>
+            </a:pPr>
+            <a:r>
+              <a:rPr sz="900" b="0">
+                <a:solidFill>
+                  <a:srgbClr val="5B6676"/>
+                </a:solidFill>
+                <a:latin typeface="Calibri"/>
+              </a:rPr>
+              <a:t>RIA — Reconfigurable Intelligence Architecture</a:t>
+            </a:r>
+          </a:p>
+        </p:txBody>
+      </p:sp>
+      <p:sp>
+        <p:nvSpPr>
+          <p:cNvPr id="8" name="Rounded Rectangle 7"/>
+          <p:cNvSpPr/>
+          <p:nvPr/>
+        </p:nvSpPr>
+        <p:spPr>
+          <a:xfrm>
+            <a:off x="548640" y="1463040"/>
+            <a:ext cx="3602736" cy="2651760"/>
+          </a:xfrm>
+          <a:prstGeom prst="roundRect">
+            <a:avLst>
+              <a:gd name="adj" fmla="val 5000"/>
+            </a:avLst>
+          </a:prstGeom>
+          <a:solidFill>
+            <a:srgbClr val="F2F5F8"/>
+          </a:solidFill>
+          <a:ln w="12700">
+            <a:solidFill>
+              <a:srgbClr val="D4DCE4"/>
+            </a:solidFill>
+          </a:ln>
+          <a:effectLst/>
+        </p:spPr>
+        <p:style>
+          <a:lnRef idx="1">
+            <a:schemeClr val="accent1"/>
+          </a:lnRef>
+          <a:fillRef idx="3">
+            <a:schemeClr val="accent1"/>
+          </a:fillRef>
+          <a:effectRef idx="2">
+            <a:schemeClr val="accent1"/>
+          </a:effectRef>
+          <a:fontRef idx="minor">
+            <a:schemeClr val="lt1"/>
+          </a:fontRef>
+        </p:style>
+        <p:txBody>
+          <a:bodyPr rtlCol="0" anchor="t" wrap="square" lIns="164592" rIns="164592" tIns="164592" bIns="164592"/>
+          <a:lstStyle/>
+          <a:p>
+            <a:pPr algn="l">
+              <a:spcAft>
+                <a:spcPts val="300"/>
+              </a:spcAft>
+            </a:pPr>
+            <a:r>
+              <a:rPr sz="1100" b="1">
+                <a:solidFill>
+                  <a:srgbClr val="2E86AB"/>
+                </a:solidFill>
+                <a:latin typeface="Calibri"/>
+              </a:rPr>
+              <a:t>YEARS 0–1</a:t>
+            </a:r>
+          </a:p>
+          <a:p>
+            <a:pPr algn="l">
+              <a:spcAft>
+                <a:spcPts val="1000"/>
+              </a:spcAft>
+            </a:pPr>
+            <a:r>
+              <a:rPr sz="1700" b="1">
+                <a:solidFill>
+                  <a:srgbClr val="0F2442"/>
+                </a:solidFill>
+                <a:latin typeface="Calibri"/>
+              </a:rPr>
+              <a:t>Survive &amp; build</a:t>
+            </a:r>
+          </a:p>
+          <a:p>
+            <a:pPr algn="l">
+              <a:spcAft>
+                <a:spcPts val="700"/>
+              </a:spcAft>
+            </a:pPr>
+            <a:r>
+              <a:rPr sz="1200" b="0">
+                <a:solidFill>
+                  <a:srgbClr val="5B6676"/>
+                </a:solidFill>
+                <a:latin typeface="Calibri"/>
+              </a:rPr>
+              <a:t>•  Grants and funded R&amp;D cover the runway</a:t>
+            </a:r>
+          </a:p>
+          <a:p>
+            <a:pPr algn="l">
+              <a:spcAft>
+                <a:spcPts val="700"/>
+              </a:spcAft>
+            </a:pPr>
+            <a:r>
+              <a:rPr sz="1200" b="0">
+                <a:solidFill>
+                  <a:srgbClr val="5B6676"/>
+                </a:solidFill>
+                <a:latin typeface="Calibri"/>
+              </a:rPr>
+              <a:t>•  Dev kits + porting services bring first paying users</a:t>
+            </a:r>
+          </a:p>
+          <a:p>
+            <a:pPr algn="l">
+              <a:spcAft>
+                <a:spcPts val="700"/>
+              </a:spcAft>
+            </a:pPr>
+            <a:r>
+              <a:rPr sz="1200" b="0">
+                <a:solidFill>
+                  <a:srgbClr val="5B6676"/>
+                </a:solidFill>
+                <a:latin typeface="Calibri"/>
+              </a:rPr>
+              <a:t>•  Every engagement stress-tests the compiler on real models</a:t>
+            </a:r>
+          </a:p>
+        </p:txBody>
+      </p:sp>
+      <p:sp>
+        <p:nvSpPr>
+          <p:cNvPr id="9" name="Rectangle 8"/>
+          <p:cNvSpPr/>
+          <p:nvPr/>
+        </p:nvSpPr>
+        <p:spPr>
+          <a:xfrm>
+            <a:off x="548640" y="1463040"/>
+            <a:ext cx="3602736" cy="64008"/>
+          </a:xfrm>
+          <a:prstGeom prst="rect">
+            <a:avLst/>
+          </a:prstGeom>
+          <a:solidFill>
+            <a:srgbClr val="2E86AB"/>
+          </a:solidFill>
+          <a:ln>
+            <a:noFill/>
+          </a:ln>
+          <a:effectLst/>
+        </p:spPr>
+        <p:style>
+          <a:lnRef idx="1">
+            <a:schemeClr val="accent1"/>
+          </a:lnRef>
+          <a:fillRef idx="3">
+            <a:schemeClr val="accent1"/>
+          </a:fillRef>
+          <a:effectRef idx="2">
+            <a:schemeClr val="accent1"/>
+          </a:effectRef>
+          <a:fontRef idx="minor">
+            <a:schemeClr val="lt1"/>
+          </a:fontRef>
+        </p:style>
+        <p:txBody>
+          <a:bodyPr rtlCol="0" anchor="ctr"/>
+          <a:lstStyle/>
+          <a:p>
+            <a:pPr algn="ctr"/>
+          </a:p>
+        </p:txBody>
+      </p:sp>
+      <p:sp>
+        <p:nvSpPr>
+          <p:cNvPr id="10" name="Rounded Rectangle 9"/>
+          <p:cNvSpPr/>
+          <p:nvPr/>
+        </p:nvSpPr>
+        <p:spPr>
+          <a:xfrm>
+            <a:off x="4297680" y="1463040"/>
+            <a:ext cx="3602736" cy="2651760"/>
+          </a:xfrm>
+          <a:prstGeom prst="roundRect">
+            <a:avLst>
+              <a:gd name="adj" fmla="val 5000"/>
+            </a:avLst>
+          </a:prstGeom>
+          <a:solidFill>
+            <a:srgbClr val="F2F5F8"/>
+          </a:solidFill>
+          <a:ln w="12700">
+            <a:solidFill>
+              <a:srgbClr val="D4DCE4"/>
+            </a:solidFill>
+          </a:ln>
+          <a:effectLst/>
+        </p:spPr>
+        <p:style>
+          <a:lnRef idx="1">
+            <a:schemeClr val="accent1"/>
+          </a:lnRef>
+          <a:fillRef idx="3">
+            <a:schemeClr val="accent1"/>
+          </a:fillRef>
+          <a:effectRef idx="2">
+            <a:schemeClr val="accent1"/>
+          </a:effectRef>
+          <a:fontRef idx="minor">
+            <a:schemeClr val="lt1"/>
+          </a:fontRef>
+        </p:style>
+        <p:txBody>
+          <a:bodyPr rtlCol="0" anchor="t" wrap="square" lIns="164592" rIns="164592" tIns="164592" bIns="164592"/>
+          <a:lstStyle/>
+          <a:p>
+            <a:pPr algn="l">
+              <a:spcAft>
+                <a:spcPts val="300"/>
+              </a:spcAft>
+            </a:pPr>
+            <a:r>
+              <a:rPr sz="1100" b="1">
+                <a:solidFill>
+                  <a:srgbClr val="2E86AB"/>
+                </a:solidFill>
+                <a:latin typeface="Calibri"/>
+              </a:rPr>
+              <a:t>YEARS 1–3</a:t>
+            </a:r>
+          </a:p>
+          <a:p>
+            <a:pPr algn="l">
+              <a:spcAft>
+                <a:spcPts val="1000"/>
+              </a:spcAft>
+            </a:pPr>
+            <a:r>
+              <a:rPr sz="1700" b="1">
+                <a:solidFill>
+                  <a:srgbClr val="0F2442"/>
+                </a:solidFill>
+                <a:latin typeface="Calibri"/>
+              </a:rPr>
+              <a:t>Product revenue</a:t>
+            </a:r>
+          </a:p>
+          <a:p>
+            <a:pPr algn="l">
+              <a:spcAft>
+                <a:spcPts val="700"/>
+              </a:spcAft>
+            </a:pPr>
+            <a:r>
+              <a:rPr sz="1200" b="0">
+                <a:solidFill>
+                  <a:srgbClr val="5B6676"/>
+                </a:solidFill>
+                <a:latin typeface="Calibri"/>
+              </a:rPr>
+              <a:t>•  FPGA modules ship into frozen-model verticals</a:t>
+            </a:r>
+          </a:p>
+          <a:p>
+            <a:pPr algn="l">
+              <a:spcAft>
+                <a:spcPts val="700"/>
+              </a:spcAft>
+            </a:pPr>
+            <a:r>
+              <a:rPr sz="1200" b="0">
+                <a:solidFill>
+                  <a:srgbClr val="5B6676"/>
+                </a:solidFill>
+                <a:latin typeface="Calibri"/>
+              </a:rPr>
+              <a:t>•  First evaluation licenses + integration NRE</a:t>
+            </a:r>
+          </a:p>
+          <a:p>
+            <a:pPr algn="l">
+              <a:spcAft>
+                <a:spcPts val="700"/>
+              </a:spcAft>
+            </a:pPr>
+            <a:r>
+              <a:rPr sz="1200" b="0">
+                <a:solidFill>
+                  <a:srgbClr val="5B6676"/>
+                </a:solidFill>
+                <a:latin typeface="Calibri"/>
+              </a:rPr>
+              <a:t>•  Compiler subscriptions begin with early licensees</a:t>
+            </a:r>
+          </a:p>
+        </p:txBody>
+      </p:sp>
+      <p:sp>
+        <p:nvSpPr>
+          <p:cNvPr id="11" name="Rectangle 10"/>
+          <p:cNvSpPr/>
+          <p:nvPr/>
+        </p:nvSpPr>
+        <p:spPr>
+          <a:xfrm>
+            <a:off x="4297680" y="1463040"/>
+            <a:ext cx="3602736" cy="64008"/>
+          </a:xfrm>
+          <a:prstGeom prst="rect">
+            <a:avLst/>
+          </a:prstGeom>
+          <a:solidFill>
+            <a:srgbClr val="2E86AB"/>
+          </a:solidFill>
+          <a:ln>
+            <a:noFill/>
+          </a:ln>
+          <a:effectLst/>
+        </p:spPr>
+        <p:style>
+          <a:lnRef idx="1">
+            <a:schemeClr val="accent1"/>
+          </a:lnRef>
+          <a:fillRef idx="3">
+            <a:schemeClr val="accent1"/>
+          </a:fillRef>
+          <a:effectRef idx="2">
+            <a:schemeClr val="accent1"/>
+          </a:effectRef>
+          <a:fontRef idx="minor">
+            <a:schemeClr val="lt1"/>
+          </a:fontRef>
+        </p:style>
+        <p:txBody>
+          <a:bodyPr rtlCol="0" anchor="ctr"/>
+          <a:lstStyle/>
+          <a:p>
+            <a:pPr algn="ctr"/>
+          </a:p>
+        </p:txBody>
+      </p:sp>
+      <p:sp>
+        <p:nvSpPr>
+          <p:cNvPr id="12" name="Rounded Rectangle 11"/>
+          <p:cNvSpPr/>
+          <p:nvPr/>
+        </p:nvSpPr>
+        <p:spPr>
+          <a:xfrm>
+            <a:off x="8046720" y="1463040"/>
+            <a:ext cx="3602736" cy="2651760"/>
+          </a:xfrm>
+          <a:prstGeom prst="roundRect">
+            <a:avLst>
+              <a:gd name="adj" fmla="val 5000"/>
+            </a:avLst>
+          </a:prstGeom>
+          <a:solidFill>
+            <a:srgbClr val="F2F5F8"/>
+          </a:solidFill>
+          <a:ln w="12700">
+            <a:solidFill>
+              <a:srgbClr val="D4DCE4"/>
+            </a:solidFill>
+          </a:ln>
+          <a:effectLst/>
+        </p:spPr>
+        <p:style>
+          <a:lnRef idx="1">
+            <a:schemeClr val="accent1"/>
+          </a:lnRef>
+          <a:fillRef idx="3">
+            <a:schemeClr val="accent1"/>
+          </a:fillRef>
+          <a:effectRef idx="2">
+            <a:schemeClr val="accent1"/>
+          </a:effectRef>
+          <a:fontRef idx="minor">
+            <a:schemeClr val="lt1"/>
+          </a:fontRef>
+        </p:style>
+        <p:txBody>
+          <a:bodyPr rtlCol="0" anchor="t" wrap="square" lIns="164592" rIns="164592" tIns="164592" bIns="164592"/>
+          <a:lstStyle/>
+          <a:p>
+            <a:pPr algn="l">
+              <a:spcAft>
+                <a:spcPts val="300"/>
+              </a:spcAft>
+            </a:pPr>
+            <a:r>
+              <a:rPr sz="1100" b="1">
+                <a:solidFill>
+                  <a:srgbClr val="2E86AB"/>
+                </a:solidFill>
+                <a:latin typeface="Calibri"/>
+              </a:rPr>
+              <a:t>YEARS 3+</a:t>
+            </a:r>
+          </a:p>
+          <a:p>
+            <a:pPr algn="l">
+              <a:spcAft>
+                <a:spcPts val="1000"/>
+              </a:spcAft>
+            </a:pPr>
+            <a:r>
+              <a:rPr sz="1700" b="1">
+                <a:solidFill>
+                  <a:srgbClr val="0F2442"/>
+                </a:solidFill>
+                <a:latin typeface="Calibri"/>
+              </a:rPr>
+              <a:t>The engine compounds</a:t>
+            </a:r>
+          </a:p>
+          <a:p>
+            <a:pPr algn="l">
+              <a:spcAft>
+                <a:spcPts val="700"/>
+              </a:spcAft>
+            </a:pPr>
+            <a:r>
+              <a:rPr sz="1200" b="0">
+                <a:solidFill>
+                  <a:srgbClr val="5B6676"/>
+                </a:solidFill>
+                <a:latin typeface="Calibri"/>
+              </a:rPr>
+              <a:t>•  Royalties ramp as customer SoCs reach production</a:t>
+            </a:r>
+          </a:p>
+          <a:p>
+            <a:pPr algn="l">
+              <a:spcAft>
+                <a:spcPts val="700"/>
+              </a:spcAft>
+            </a:pPr>
+            <a:r>
+              <a:rPr sz="1200" b="0">
+                <a:solidFill>
+                  <a:srgbClr val="5B6676"/>
+                </a:solidFill>
+                <a:latin typeface="Calibri"/>
+              </a:rPr>
+              <a:t>•  Subscriptions renew on measurable scheduling gains</a:t>
+            </a:r>
+          </a:p>
+          <a:p>
+            <a:pPr algn="l">
+              <a:spcAft>
+                <a:spcPts val="700"/>
+              </a:spcAft>
+            </a:pPr>
+            <a:r>
+              <a:rPr sz="1200" b="0">
+                <a:solidFill>
+                  <a:srgbClr val="5B6676"/>
+                </a:solidFill>
+                <a:latin typeface="Calibri"/>
+              </a:rPr>
+              <a:t>•  Optional chiplet tier opens higher-margin deals</a:t>
+            </a:r>
+          </a:p>
+        </p:txBody>
+      </p:sp>
+      <p:sp>
+        <p:nvSpPr>
+          <p:cNvPr id="13" name="Rectangle 12"/>
+          <p:cNvSpPr/>
+          <p:nvPr/>
+        </p:nvSpPr>
+        <p:spPr>
+          <a:xfrm>
+            <a:off x="8046720" y="1463040"/>
+            <a:ext cx="3602736" cy="64008"/>
+          </a:xfrm>
+          <a:prstGeom prst="rect">
+            <a:avLst/>
+          </a:prstGeom>
+          <a:solidFill>
+            <a:srgbClr val="2E86AB"/>
+          </a:solidFill>
+          <a:ln>
+            <a:noFill/>
+          </a:ln>
+          <a:effectLst/>
+        </p:spPr>
+        <p:style>
+          <a:lnRef idx="1">
+            <a:schemeClr val="accent1"/>
+          </a:lnRef>
+          <a:fillRef idx="3">
+            <a:schemeClr val="accent1"/>
+          </a:fillRef>
+          <a:effectRef idx="2">
+            <a:schemeClr val="accent1"/>
+          </a:effectRef>
+          <a:fontRef idx="minor">
+            <a:schemeClr val="lt1"/>
+          </a:fontRef>
+        </p:style>
+        <p:txBody>
+          <a:bodyPr rtlCol="0" anchor="ctr"/>
+          <a:lstStyle/>
+          <a:p>
+            <a:pPr algn="ctr"/>
+          </a:p>
+        </p:txBody>
+      </p:sp>
+      <p:sp>
+        <p:nvSpPr>
+          <p:cNvPr id="14" name="TextBox 13"/>
+          <p:cNvSpPr txBox="1"/>
+          <p:nvPr/>
+        </p:nvSpPr>
+        <p:spPr>
+          <a:xfrm>
+            <a:off x="548640" y="4434840"/>
+            <a:ext cx="11064240" cy="1737360"/>
+          </a:xfrm>
+          <a:prstGeom prst="rect">
+            <a:avLst/>
+          </a:prstGeom>
+          <a:noFill/>
+        </p:spPr>
+        <p:txBody>
+          <a:bodyPr wrap="square">
+            <a:spAutoFit/>
+          </a:bodyPr>
+          <a:lstStyle/>
+          <a:p>
+            <a:pPr>
+              <a:spcAft>
+                <a:spcPts val="1100"/>
+              </a:spcAft>
+            </a:pPr>
+            <a:r>
+              <a:rPr sz="1300">
+                <a:solidFill>
+                  <a:srgbClr val="2E86AB"/>
+                </a:solidFill>
+                <a:latin typeface="Calibri"/>
+              </a:rPr>
+              <a:t>▪  </a:t>
+            </a:r>
+            <a:r>
+              <a:rPr sz="1300" b="1">
+                <a:solidFill>
+                  <a:srgbClr val="1F2937"/>
+                </a:solidFill>
+                <a:latin typeface="Calibri"/>
+              </a:rPr>
+              <a:t>Royalty lag is real — </a:t>
+            </a:r>
+            <a:r>
+              <a:rPr sz="1300">
+                <a:solidFill>
+                  <a:srgbClr val="5B6676"/>
+                </a:solidFill>
+                <a:latin typeface="Calibri"/>
+              </a:rPr>
+              <a:t>design win to tape-out to production ramp takes 3–4 years — the early streams exist to bridge exactly that gap, and we say so.</a:t>
+            </a:r>
+          </a:p>
+          <a:p>
+            <a:pPr>
+              <a:spcAft>
+                <a:spcPts val="1100"/>
+              </a:spcAft>
+            </a:pPr>
+            <a:r>
+              <a:rPr sz="1300">
+                <a:solidFill>
+                  <a:srgbClr val="2E86AB"/>
+                </a:solidFill>
+                <a:latin typeface="Calibri"/>
+              </a:rPr>
+              <a:t>▪  </a:t>
+            </a:r>
+            <a:r>
+              <a:rPr sz="1300" b="1">
+                <a:solidFill>
+                  <a:srgbClr val="1F2937"/>
+                </a:solidFill>
+                <a:latin typeface="Calibri"/>
+              </a:rPr>
+              <a:t>Services are a bridge, not the business — </a:t>
+            </a:r>
+            <a:r>
+              <a:rPr sz="1300">
+                <a:solidFill>
+                  <a:srgbClr val="5B6676"/>
+                </a:solidFill>
+                <a:latin typeface="Calibri"/>
+              </a:rPr>
+              <a:t>capped at a fixed share of revenue and headcount, or they quietly consume the product roadmap.</a:t>
+            </a:r>
+          </a:p>
+          <a:p>
+            <a:pPr>
+              <a:spcAft>
+                <a:spcPts val="1100"/>
+              </a:spcAft>
+            </a:pPr>
+            <a:r>
+              <a:rPr sz="1300">
+                <a:solidFill>
+                  <a:srgbClr val="2E86AB"/>
+                </a:solidFill>
+                <a:latin typeface="Calibri"/>
+              </a:rPr>
+              <a:t>▪  </a:t>
+            </a:r>
+            <a:r>
+              <a:rPr sz="1300" b="1">
+                <a:solidFill>
+                  <a:srgbClr val="1F2937"/>
+                </a:solidFill>
+                <a:latin typeface="Calibri"/>
+              </a:rPr>
+              <a:t>One product underneath all eight streams — </a:t>
+            </a:r>
+            <a:r>
+              <a:rPr sz="1300">
+                <a:solidFill>
+                  <a:srgbClr val="5B6676"/>
+                </a:solidFill>
+                <a:latin typeface="Calibri"/>
+              </a:rPr>
+              <a:t>modules, services, licenses, and royalties all monetize the same tile + compiler — no stream forks the engineering.</a:t>
+            </a:r>
+          </a:p>
+        </p:txBody>
+      </p:sp>
+    </p:spTree>
+  </p:cSld>
+  <p:clrMapOvr>
+    <a:masterClrMapping/>
+  </p:clrMapOvr>
+</p:sld>
+</file>
+
+<file path=ppt/slides/slide16.xml><?xml version="1.0" encoding="utf-8"?>
+<p:sld xmlns:a="http://schemas.openxmlformats.org/drawingml/2006/main" xmlns:p="http://schemas.openxmlformats.org/presentationml/2006/main" xmlns:r="http://schemas.openxmlformats.org/officeDocument/2006/relationships">
+  <p:cSld>
+    <p:spTree>
+      <p:nvGrpSpPr>
+        <p:cNvPr id="1" name=""/>
+        <p:cNvGrpSpPr/>
+        <p:nvPr/>
+      </p:nvGrpSpPr>
+      <p:grpSpPr/>
+      <p:sp>
+        <p:nvSpPr>
+          <p:cNvPr id="2" name="Rectangle 1"/>
+          <p:cNvSpPr/>
+          <p:nvPr/>
+        </p:nvSpPr>
+        <p:spPr>
+          <a:xfrm>
+            <a:off x="0" y="0"/>
+            <a:ext cx="12191695" cy="6858000"/>
+          </a:xfrm>
+          <a:prstGeom prst="rect">
+            <a:avLst/>
+          </a:prstGeom>
+          <a:solidFill>
+            <a:srgbClr val="FFFFFF"/>
+          </a:solidFill>
+          <a:ln>
+            <a:noFill/>
+          </a:ln>
+          <a:effectLst/>
+        </p:spPr>
+        <p:style>
+          <a:lnRef idx="1">
+            <a:schemeClr val="accent1"/>
+          </a:lnRef>
+          <a:fillRef idx="3">
+            <a:schemeClr val="accent1"/>
+          </a:fillRef>
+          <a:effectRef idx="2">
+            <a:schemeClr val="accent1"/>
+          </a:effectRef>
+          <a:fontRef idx="minor">
+            <a:schemeClr val="lt1"/>
+          </a:fontRef>
+        </p:style>
+        <p:txBody>
+          <a:bodyPr rtlCol="0" anchor="ctr"/>
+          <a:lstStyle/>
+          <a:p>
+            <a:pPr algn="ctr"/>
+          </a:p>
+        </p:txBody>
+      </p:sp>
+      <p:sp>
+        <p:nvSpPr>
+          <p:cNvPr id="3" name="TextBox 2"/>
+          <p:cNvSpPr txBox="1"/>
+          <p:nvPr/>
+        </p:nvSpPr>
+        <p:spPr>
+          <a:xfrm>
+            <a:off x="548640" y="274320"/>
+            <a:ext cx="8229600" cy="274320"/>
+          </a:xfrm>
+          <a:prstGeom prst="rect">
+            <a:avLst/>
+          </a:prstGeom>
+          <a:noFill/>
+        </p:spPr>
+        <p:txBody>
+          <a:bodyPr wrap="square" anchor="t" lIns="18288" rIns="18288" tIns="18288" bIns="18288">
+            <a:spAutoFit/>
+          </a:bodyPr>
+          <a:lstStyle/>
+          <a:p>
+            <a:pPr algn="l">
+              <a:spcAft>
+                <a:spcPts val="0"/>
+              </a:spcAft>
+            </a:pPr>
+            <a:r>
+              <a:rPr sz="1100" b="1">
+                <a:solidFill>
+                  <a:srgbClr val="2E86AB"/>
+                </a:solidFill>
+                <a:latin typeface="Calibri"/>
+              </a:rPr>
+              <a:t>EXECUTION</a:t>
+            </a:r>
+          </a:p>
+        </p:txBody>
+      </p:sp>
+      <p:sp>
+        <p:nvSpPr>
+          <p:cNvPr id="4" name="TextBox 3"/>
+          <p:cNvSpPr txBox="1"/>
+          <p:nvPr/>
+        </p:nvSpPr>
+        <p:spPr>
+          <a:xfrm>
+            <a:off x="548640" y="548640"/>
+            <a:ext cx="11091672" cy="548640"/>
+          </a:xfrm>
+          <a:prstGeom prst="rect">
+            <a:avLst/>
+          </a:prstGeom>
+          <a:noFill/>
+        </p:spPr>
+        <p:txBody>
+          <a:bodyPr wrap="square" anchor="t" lIns="18288" rIns="18288" tIns="18288" bIns="18288">
+            <a:spAutoFit/>
+          </a:bodyPr>
+          <a:lstStyle/>
+          <a:p>
+            <a:pPr algn="l">
+              <a:spcAft>
+                <a:spcPts val="0"/>
+              </a:spcAft>
+            </a:pPr>
+            <a:r>
+              <a:rPr sz="2600" b="1">
+                <a:solidFill>
+                  <a:srgbClr val="0F2442"/>
+                </a:solidFill>
+                <a:latin typeface="Calibri"/>
+              </a:rPr>
+              <a:t>Roadmap — milestones, not checkmarks</a:t>
+            </a:r>
+          </a:p>
+        </p:txBody>
+      </p:sp>
+      <p:sp>
+        <p:nvSpPr>
+          <p:cNvPr id="5" name="Rectangle 4"/>
+          <p:cNvSpPr/>
+          <p:nvPr/>
+        </p:nvSpPr>
+        <p:spPr>
+          <a:xfrm>
+            <a:off x="548640" y="1078992"/>
+            <a:ext cx="1371600" cy="41148"/>
+          </a:xfrm>
+          <a:prstGeom prst="rect">
+            <a:avLst/>
+          </a:prstGeom>
+          <a:solidFill>
+            <a:srgbClr val="2E86AB"/>
+          </a:solidFill>
+          <a:ln>
+            <a:noFill/>
+          </a:ln>
+          <a:effectLst/>
+        </p:spPr>
+        <p:style>
+          <a:lnRef idx="1">
+            <a:schemeClr val="accent1"/>
+          </a:lnRef>
+          <a:fillRef idx="3">
+            <a:schemeClr val="accent1"/>
+          </a:fillRef>
+          <a:effectRef idx="2">
+            <a:schemeClr val="accent1"/>
+          </a:effectRef>
+          <a:fontRef idx="minor">
+            <a:schemeClr val="lt1"/>
+          </a:fontRef>
+        </p:style>
+        <p:txBody>
+          <a:bodyPr rtlCol="0" anchor="ctr"/>
+          <a:lstStyle/>
+          <a:p>
+            <a:pPr algn="ctr"/>
+          </a:p>
+        </p:txBody>
+      </p:sp>
+      <p:sp>
+        <p:nvSpPr>
+          <p:cNvPr id="6" name="TextBox 5"/>
+          <p:cNvSpPr txBox="1"/>
+          <p:nvPr/>
+        </p:nvSpPr>
+        <p:spPr>
+          <a:xfrm>
+            <a:off x="10911535" y="6473952"/>
+            <a:ext cx="822960" cy="274320"/>
+          </a:xfrm>
+          <a:prstGeom prst="rect">
+            <a:avLst/>
+          </a:prstGeom>
+          <a:noFill/>
+        </p:spPr>
+        <p:txBody>
+          <a:bodyPr wrap="square" anchor="t" lIns="18288" rIns="18288" tIns="18288" bIns="18288">
+            <a:spAutoFit/>
+          </a:bodyPr>
+          <a:lstStyle/>
+          <a:p>
+            <a:pPr algn="r">
+              <a:spcAft>
+                <a:spcPts val="0"/>
+              </a:spcAft>
+            </a:pPr>
+            <a:r>
+              <a:rPr sz="1000" b="0">
+                <a:solidFill>
+                  <a:srgbClr val="5B6676"/>
+                </a:solidFill>
+                <a:latin typeface="Calibri"/>
+              </a:rPr>
+              <a:t>16</a:t>
+            </a:r>
+          </a:p>
+        </p:txBody>
+      </p:sp>
+      <p:sp>
+        <p:nvSpPr>
+          <p:cNvPr id="7" name="TextBox 6"/>
+          <p:cNvSpPr txBox="1"/>
+          <p:nvPr/>
+        </p:nvSpPr>
+        <p:spPr>
+          <a:xfrm>
+            <a:off x="548640" y="6473952"/>
+            <a:ext cx="5486400" cy="274320"/>
+          </a:xfrm>
+          <a:prstGeom prst="rect">
+            <a:avLst/>
+          </a:prstGeom>
+          <a:noFill/>
+        </p:spPr>
+        <p:txBody>
+          <a:bodyPr wrap="square" anchor="t" lIns="18288" rIns="18288" tIns="18288" bIns="18288">
+            <a:spAutoFit/>
+          </a:bodyPr>
+          <a:lstStyle/>
+          <a:p>
+            <a:pPr algn="l">
+              <a:spcAft>
+                <a:spcPts val="0"/>
+              </a:spcAft>
+            </a:pPr>
+            <a:r>
+              <a:rPr sz="900" b="0">
+                <a:solidFill>
+                  <a:srgbClr val="5B6676"/>
+                </a:solidFill>
+                <a:latin typeface="Calibri"/>
+              </a:rPr>
+              <a:t>RIA — Reconfigurable Intelligence Architecture</a:t>
+            </a:r>
+          </a:p>
+        </p:txBody>
+      </p:sp>
+      <p:sp>
+        <p:nvSpPr>
+          <p:cNvPr id="8" name="Rounded Rectangle 7"/>
+          <p:cNvSpPr/>
+          <p:nvPr/>
+        </p:nvSpPr>
+        <p:spPr>
+          <a:xfrm>
+            <a:off x="548640" y="1554480"/>
+            <a:ext cx="2679192" cy="3291840"/>
+          </a:xfrm>
+          <a:prstGeom prst="roundRect">
+            <a:avLst>
+              <a:gd name="adj" fmla="val 4500"/>
+            </a:avLst>
+          </a:prstGeom>
+          <a:solidFill>
+            <a:srgbClr val="F2F5F8"/>
+          </a:solidFill>
+          <a:ln w="12700">
+            <a:solidFill>
+              <a:srgbClr val="D4DCE4"/>
+            </a:solidFill>
+          </a:ln>
+          <a:effectLst/>
+        </p:spPr>
+        <p:style>
+          <a:lnRef idx="1">
+            <a:schemeClr val="accent1"/>
+          </a:lnRef>
+          <a:fillRef idx="3">
+            <a:schemeClr val="accent1"/>
+          </a:fillRef>
+          <a:effectRef idx="2">
+            <a:schemeClr val="accent1"/>
+          </a:effectRef>
+          <a:fontRef idx="minor">
+            <a:schemeClr val="lt1"/>
+          </a:fontRef>
+        </p:style>
+        <p:txBody>
+          <a:bodyPr rtlCol="0" anchor="t" wrap="square" lIns="164592" rIns="164592" tIns="164592" bIns="164592"/>
+          <a:lstStyle/>
+          <a:p>
+            <a:pPr algn="l">
+              <a:spcAft>
+                <a:spcPts val="300"/>
+              </a:spcAft>
+            </a:pPr>
+            <a:r>
+              <a:rPr sz="1050" b="1">
+                <a:solidFill>
+                  <a:srgbClr val="2E86AB"/>
+                </a:solidFill>
+                <a:latin typeface="Calibri"/>
+              </a:rPr>
+              <a:t>Phase 1  •  months 0–6</a:t>
+            </a:r>
+          </a:p>
+          <a:p>
+            <a:pPr algn="l">
+              <a:spcAft>
+                <a:spcPts val="1000"/>
+              </a:spcAft>
+            </a:pPr>
+            <a:r>
+              <a:rPr sz="1700" b="1">
+                <a:solidFill>
+                  <a:srgbClr val="0F2442"/>
+                </a:solidFill>
+                <a:latin typeface="Calibri"/>
+              </a:rPr>
+              <a:t>Foundations</a:t>
+            </a:r>
+          </a:p>
+          <a:p>
+            <a:pPr algn="l">
+              <a:spcAft>
+                <a:spcPts val="700"/>
+              </a:spcAft>
+            </a:pPr>
+            <a:r>
+              <a:rPr sz="1150" b="0">
+                <a:solidFill>
+                  <a:srgbClr val="5B6676"/>
+                </a:solidFill>
+                <a:latin typeface="Calibri"/>
+              </a:rPr>
+              <a:t>•  Tile RTL + ISA specification frozen</a:t>
+            </a:r>
+          </a:p>
+          <a:p>
+            <a:pPr algn="l">
+              <a:spcAft>
+                <a:spcPts val="700"/>
+              </a:spcAft>
+            </a:pPr>
+            <a:r>
+              <a:rPr sz="1150" b="0">
+                <a:solidFill>
+                  <a:srgbClr val="5B6676"/>
+                </a:solidFill>
+                <a:latin typeface="Calibri"/>
+              </a:rPr>
+              <a:t>•  Single-tile FPGA validation (GEMM, conv, vector ops)</a:t>
+            </a:r>
+          </a:p>
+          <a:p>
+            <a:pPr algn="l">
+              <a:spcAft>
+                <a:spcPts val="700"/>
+              </a:spcAft>
+            </a:pPr>
+            <a:r>
+              <a:rPr sz="1150" b="0">
+                <a:solidFill>
+                  <a:srgbClr val="5B6676"/>
+                </a:solidFill>
+                <a:latin typeface="Calibri"/>
+              </a:rPr>
+              <a:t>•  Compiler MVP: ONNX → microcode for core opset</a:t>
+            </a:r>
+          </a:p>
+        </p:txBody>
+      </p:sp>
+      <p:sp>
+        <p:nvSpPr>
+          <p:cNvPr id="9" name="Rectangle 8"/>
+          <p:cNvSpPr/>
+          <p:nvPr/>
+        </p:nvSpPr>
+        <p:spPr>
+          <a:xfrm>
+            <a:off x="548640" y="1554480"/>
+            <a:ext cx="2679192" cy="64008"/>
+          </a:xfrm>
+          <a:prstGeom prst="rect">
+            <a:avLst/>
+          </a:prstGeom>
+          <a:solidFill>
+            <a:srgbClr val="2E86AB"/>
+          </a:solidFill>
+          <a:ln>
+            <a:noFill/>
+          </a:ln>
+          <a:effectLst/>
+        </p:spPr>
+        <p:style>
+          <a:lnRef idx="1">
+            <a:schemeClr val="accent1"/>
+          </a:lnRef>
+          <a:fillRef idx="3">
+            <a:schemeClr val="accent1"/>
+          </a:fillRef>
+          <a:effectRef idx="2">
+            <a:schemeClr val="accent1"/>
+          </a:effectRef>
+          <a:fontRef idx="minor">
+            <a:schemeClr val="lt1"/>
+          </a:fontRef>
+        </p:style>
+        <p:txBody>
+          <a:bodyPr rtlCol="0" anchor="ctr"/>
+          <a:lstStyle/>
+          <a:p>
+            <a:pPr algn="ctr"/>
+          </a:p>
+        </p:txBody>
+      </p:sp>
+      <p:sp>
+        <p:nvSpPr>
+          <p:cNvPr id="10" name="Rounded Rectangle 9"/>
+          <p:cNvSpPr/>
+          <p:nvPr/>
+        </p:nvSpPr>
+        <p:spPr>
+          <a:xfrm>
+            <a:off x="3355848" y="1554480"/>
+            <a:ext cx="2679192" cy="3291840"/>
+          </a:xfrm>
+          <a:prstGeom prst="roundRect">
+            <a:avLst>
+              <a:gd name="adj" fmla="val 4500"/>
+            </a:avLst>
+          </a:prstGeom>
+          <a:solidFill>
+            <a:srgbClr val="F2F5F8"/>
+          </a:solidFill>
+          <a:ln w="12700">
+            <a:solidFill>
+              <a:srgbClr val="D4DCE4"/>
+            </a:solidFill>
+          </a:ln>
+          <a:effectLst/>
+        </p:spPr>
+        <p:style>
+          <a:lnRef idx="1">
+            <a:schemeClr val="accent1"/>
+          </a:lnRef>
+          <a:fillRef idx="3">
+            <a:schemeClr val="accent1"/>
+          </a:fillRef>
+          <a:effectRef idx="2">
+            <a:schemeClr val="accent1"/>
+          </a:effectRef>
+          <a:fontRef idx="minor">
+            <a:schemeClr val="lt1"/>
+          </a:fontRef>
+        </p:style>
+        <p:txBody>
+          <a:bodyPr rtlCol="0" anchor="t" wrap="square" lIns="164592" rIns="164592" tIns="164592" bIns="164592"/>
+          <a:lstStyle/>
+          <a:p>
+            <a:pPr algn="l">
+              <a:spcAft>
+                <a:spcPts val="300"/>
+              </a:spcAft>
+            </a:pPr>
+            <a:r>
+              <a:rPr sz="1050" b="1">
+                <a:solidFill>
+                  <a:srgbClr val="2E86AB"/>
+                </a:solidFill>
+                <a:latin typeface="Calibri"/>
+              </a:rPr>
+              <a:t>Phase 2  •  months 6–12</a:t>
+            </a:r>
+          </a:p>
+          <a:p>
+            <a:pPr algn="l">
+              <a:spcAft>
+                <a:spcPts val="1000"/>
+              </a:spcAft>
+            </a:pPr>
+            <a:r>
+              <a:rPr sz="1700" b="1">
+                <a:solidFill>
+                  <a:srgbClr val="0F2442"/>
+                </a:solidFill>
+                <a:latin typeface="Calibri"/>
+              </a:rPr>
+              <a:t>Fabric</a:t>
+            </a:r>
+          </a:p>
+          <a:p>
+            <a:pPr algn="l">
+              <a:spcAft>
+                <a:spcPts val="700"/>
+              </a:spcAft>
+            </a:pPr>
+            <a:r>
+              <a:rPr sz="1150" b="0">
+                <a:solidFill>
+                  <a:srgbClr val="5B6676"/>
+                </a:solidFill>
+                <a:latin typeface="Calibri"/>
+              </a:rPr>
+              <a:t>•  Multi-tile array + NoC + scheduler subsystem</a:t>
+            </a:r>
+          </a:p>
+          <a:p>
+            <a:pPr algn="l">
+              <a:spcAft>
+                <a:spcPts val="700"/>
+              </a:spcAft>
+            </a:pPr>
+            <a:r>
+              <a:rPr sz="1150" b="0">
+                <a:solidFill>
+                  <a:srgbClr val="5B6676"/>
+                </a:solidFill>
+                <a:latin typeface="Calibri"/>
+              </a:rPr>
+              <a:t>•  MobileNetV2 end-to-end on FPGA</a:t>
+            </a:r>
+          </a:p>
+          <a:p>
+            <a:pPr algn="l">
+              <a:spcAft>
+                <a:spcPts val="700"/>
+              </a:spcAft>
+            </a:pPr>
+            <a:r>
+              <a:rPr sz="1150" b="0">
+                <a:solidFill>
+                  <a:srgbClr val="5B6676"/>
+                </a:solidFill>
+                <a:latin typeface="Calibri"/>
+              </a:rPr>
+              <a:t>•  First utilization + power measurements</a:t>
+            </a:r>
+          </a:p>
+        </p:txBody>
+      </p:sp>
+      <p:sp>
+        <p:nvSpPr>
+          <p:cNvPr id="11" name="Rectangle 10"/>
+          <p:cNvSpPr/>
+          <p:nvPr/>
+        </p:nvSpPr>
+        <p:spPr>
+          <a:xfrm>
+            <a:off x="3355848" y="1554480"/>
+            <a:ext cx="2679192" cy="64008"/>
+          </a:xfrm>
+          <a:prstGeom prst="rect">
+            <a:avLst/>
+          </a:prstGeom>
+          <a:solidFill>
+            <a:srgbClr val="2E86AB"/>
+          </a:solidFill>
+          <a:ln>
+            <a:noFill/>
+          </a:ln>
+          <a:effectLst/>
+        </p:spPr>
+        <p:style>
+          <a:lnRef idx="1">
+            <a:schemeClr val="accent1"/>
+          </a:lnRef>
+          <a:fillRef idx="3">
+            <a:schemeClr val="accent1"/>
+          </a:fillRef>
+          <a:effectRef idx="2">
+            <a:schemeClr val="accent1"/>
+          </a:effectRef>
+          <a:fontRef idx="minor">
+            <a:schemeClr val="lt1"/>
+          </a:fontRef>
+        </p:style>
+        <p:txBody>
+          <a:bodyPr rtlCol="0" anchor="ctr"/>
+          <a:lstStyle/>
+          <a:p>
+            <a:pPr algn="ctr"/>
+          </a:p>
+        </p:txBody>
+      </p:sp>
+      <p:sp>
+        <p:nvSpPr>
+          <p:cNvPr id="12" name="Rounded Rectangle 11"/>
+          <p:cNvSpPr/>
+          <p:nvPr/>
+        </p:nvSpPr>
+        <p:spPr>
+          <a:xfrm>
+            <a:off x="6163056" y="1554480"/>
+            <a:ext cx="2679192" cy="3291840"/>
+          </a:xfrm>
+          <a:prstGeom prst="roundRect">
+            <a:avLst>
+              <a:gd name="adj" fmla="val 4500"/>
+            </a:avLst>
+          </a:prstGeom>
+          <a:solidFill>
+            <a:srgbClr val="F2F5F8"/>
+          </a:solidFill>
+          <a:ln w="12700">
+            <a:solidFill>
+              <a:srgbClr val="D4DCE4"/>
+            </a:solidFill>
+          </a:ln>
+          <a:effectLst/>
+        </p:spPr>
+        <p:style>
+          <a:lnRef idx="1">
+            <a:schemeClr val="accent1"/>
+          </a:lnRef>
+          <a:fillRef idx="3">
+            <a:schemeClr val="accent1"/>
+          </a:fillRef>
+          <a:effectRef idx="2">
+            <a:schemeClr val="accent1"/>
+          </a:effectRef>
+          <a:fontRef idx="minor">
+            <a:schemeClr val="lt1"/>
+          </a:fontRef>
+        </p:style>
+        <p:txBody>
+          <a:bodyPr rtlCol="0" anchor="t" wrap="square" lIns="164592" rIns="164592" tIns="164592" bIns="164592"/>
+          <a:lstStyle/>
+          <a:p>
+            <a:pPr algn="l">
+              <a:spcAft>
+                <a:spcPts val="300"/>
+              </a:spcAft>
+            </a:pPr>
+            <a:r>
+              <a:rPr sz="1050" b="1">
+                <a:solidFill>
+                  <a:srgbClr val="2E86AB"/>
+                </a:solidFill>
+                <a:latin typeface="Calibri"/>
+              </a:rPr>
+              <a:t>Phase 3  •  months 12–18</a:t>
+            </a:r>
+          </a:p>
+          <a:p>
+            <a:pPr algn="l">
+              <a:spcAft>
+                <a:spcPts val="1000"/>
+              </a:spcAft>
+            </a:pPr>
+            <a:r>
+              <a:rPr sz="1700" b="1">
+                <a:solidFill>
+                  <a:srgbClr val="0F2442"/>
+                </a:solidFill>
+                <a:latin typeface="Calibri"/>
+              </a:rPr>
+              <a:t>Proof</a:t>
+            </a:r>
+          </a:p>
+          <a:p>
+            <a:pPr algn="l">
+              <a:spcAft>
+                <a:spcPts val="700"/>
+              </a:spcAft>
+            </a:pPr>
+            <a:r>
+              <a:rPr sz="1150" b="0">
+                <a:solidFill>
+                  <a:srgbClr val="5B6676"/>
+                </a:solidFill>
+                <a:latin typeface="Calibri"/>
+              </a:rPr>
+              <a:t>•  Transformer support in compiler</a:t>
+            </a:r>
+          </a:p>
+          <a:p>
+            <a:pPr algn="l">
+              <a:spcAft>
+                <a:spcPts val="700"/>
+              </a:spcAft>
+            </a:pPr>
+            <a:r>
+              <a:rPr sz="1150" b="0">
+                <a:solidFill>
+                  <a:srgbClr val="5B6676"/>
+                </a:solidFill>
+                <a:latin typeface="Calibri"/>
+              </a:rPr>
+              <a:t>•  Flagship demo: two model families, one bitstream</a:t>
+            </a:r>
+          </a:p>
+          <a:p>
+            <a:pPr algn="l">
+              <a:spcAft>
+                <a:spcPts val="700"/>
+              </a:spcAft>
+            </a:pPr>
+            <a:r>
+              <a:rPr sz="1150" b="0">
+                <a:solidFill>
+                  <a:srgbClr val="5B6676"/>
+                </a:solidFill>
+                <a:latin typeface="Calibri"/>
+              </a:rPr>
+              <a:t>•  Publication + benchmark report</a:t>
+            </a:r>
+          </a:p>
+        </p:txBody>
+      </p:sp>
+      <p:sp>
+        <p:nvSpPr>
+          <p:cNvPr id="13" name="Rectangle 12"/>
+          <p:cNvSpPr/>
+          <p:nvPr/>
+        </p:nvSpPr>
+        <p:spPr>
+          <a:xfrm>
+            <a:off x="6163056" y="1554480"/>
+            <a:ext cx="2679192" cy="64008"/>
+          </a:xfrm>
+          <a:prstGeom prst="rect">
+            <a:avLst/>
+          </a:prstGeom>
+          <a:solidFill>
+            <a:srgbClr val="2E86AB"/>
+          </a:solidFill>
+          <a:ln>
+            <a:noFill/>
+          </a:ln>
+          <a:effectLst/>
+        </p:spPr>
+        <p:style>
+          <a:lnRef idx="1">
+            <a:schemeClr val="accent1"/>
+          </a:lnRef>
+          <a:fillRef idx="3">
+            <a:schemeClr val="accent1"/>
+          </a:fillRef>
+          <a:effectRef idx="2">
+            <a:schemeClr val="accent1"/>
+          </a:effectRef>
+          <a:fontRef idx="minor">
+            <a:schemeClr val="lt1"/>
+          </a:fontRef>
+        </p:style>
+        <p:txBody>
+          <a:bodyPr rtlCol="0" anchor="ctr"/>
+          <a:lstStyle/>
+          <a:p>
+            <a:pPr algn="ctr"/>
+          </a:p>
+        </p:txBody>
+      </p:sp>
+      <p:sp>
+        <p:nvSpPr>
+          <p:cNvPr id="14" name="Rounded Rectangle 13"/>
+          <p:cNvSpPr/>
+          <p:nvPr/>
+        </p:nvSpPr>
+        <p:spPr>
+          <a:xfrm>
+            <a:off x="8970264" y="1554480"/>
+            <a:ext cx="2679192" cy="3291840"/>
+          </a:xfrm>
+          <a:prstGeom prst="roundRect">
+            <a:avLst>
+              <a:gd name="adj" fmla="val 4500"/>
+            </a:avLst>
+          </a:prstGeom>
+          <a:solidFill>
+            <a:srgbClr val="F2F5F8"/>
+          </a:solidFill>
+          <a:ln w="12700">
+            <a:solidFill>
+              <a:srgbClr val="D4DCE4"/>
+            </a:solidFill>
+          </a:ln>
+          <a:effectLst/>
+        </p:spPr>
+        <p:style>
+          <a:lnRef idx="1">
+            <a:schemeClr val="accent1"/>
+          </a:lnRef>
+          <a:fillRef idx="3">
+            <a:schemeClr val="accent1"/>
+          </a:fillRef>
+          <a:effectRef idx="2">
+            <a:schemeClr val="accent1"/>
+          </a:effectRef>
+          <a:fontRef idx="minor">
+            <a:schemeClr val="lt1"/>
+          </a:fontRef>
+        </p:style>
+        <p:txBody>
+          <a:bodyPr rtlCol="0" anchor="t" wrap="square" lIns="164592" rIns="164592" tIns="164592" bIns="164592"/>
+          <a:lstStyle/>
+          <a:p>
+            <a:pPr algn="l">
+              <a:spcAft>
+                <a:spcPts val="300"/>
+              </a:spcAft>
+            </a:pPr>
+            <a:r>
+              <a:rPr sz="1050" b="1">
+                <a:solidFill>
+                  <a:srgbClr val="2E86AB"/>
+                </a:solidFill>
+                <a:latin typeface="Calibri"/>
+              </a:rPr>
+              <a:t>Phase 4  •  months 18–24</a:t>
+            </a:r>
+          </a:p>
+          <a:p>
+            <a:pPr algn="l">
+              <a:spcAft>
+                <a:spcPts val="1000"/>
+              </a:spcAft>
+            </a:pPr>
+            <a:r>
+              <a:rPr sz="1700" b="1">
+                <a:solidFill>
+                  <a:srgbClr val="0F2442"/>
+                </a:solidFill>
+                <a:latin typeface="Calibri"/>
+              </a:rPr>
+              <a:t>Product</a:t>
+            </a:r>
+          </a:p>
+          <a:p>
+            <a:pPr algn="l">
+              <a:spcAft>
+                <a:spcPts val="700"/>
+              </a:spcAft>
+            </a:pPr>
+            <a:r>
+              <a:rPr sz="1150" b="0">
+                <a:solidFill>
+                  <a:srgbClr val="5B6676"/>
+                </a:solidFill>
+                <a:latin typeface="Calibri"/>
+              </a:rPr>
+              <a:t>•  ASIC hardening + PPA characterization</a:t>
+            </a:r>
+          </a:p>
+          <a:p>
+            <a:pPr algn="l">
+              <a:spcAft>
+                <a:spcPts val="700"/>
+              </a:spcAft>
+            </a:pPr>
+            <a:r>
+              <a:rPr sz="1150" b="0">
+                <a:solidFill>
+                  <a:srgbClr val="5B6676"/>
+                </a:solidFill>
+                <a:latin typeface="Calibri"/>
+              </a:rPr>
+              <a:t>•  Design-time configurator (tile-mix tool)</a:t>
+            </a:r>
+          </a:p>
+          <a:p>
+            <a:pPr algn="l">
+              <a:spcAft>
+                <a:spcPts val="700"/>
+              </a:spcAft>
+            </a:pPr>
+            <a:r>
+              <a:rPr sz="1150" b="0">
+                <a:solidFill>
+                  <a:srgbClr val="5B6676"/>
+                </a:solidFill>
+                <a:latin typeface="Calibri"/>
+              </a:rPr>
+              <a:t>•  First evaluation licenses signed</a:t>
+            </a:r>
+          </a:p>
+        </p:txBody>
+      </p:sp>
+      <p:sp>
+        <p:nvSpPr>
+          <p:cNvPr id="15" name="Rectangle 14"/>
+          <p:cNvSpPr/>
+          <p:nvPr/>
+        </p:nvSpPr>
+        <p:spPr>
+          <a:xfrm>
+            <a:off x="8970264" y="1554480"/>
+            <a:ext cx="2679192" cy="64008"/>
+          </a:xfrm>
+          <a:prstGeom prst="rect">
+            <a:avLst/>
+          </a:prstGeom>
+          <a:solidFill>
+            <a:srgbClr val="2E86AB"/>
+          </a:solidFill>
+          <a:ln>
+            <a:noFill/>
+          </a:ln>
+          <a:effectLst/>
+        </p:spPr>
+        <p:style>
+          <a:lnRef idx="1">
+            <a:schemeClr val="accent1"/>
+          </a:lnRef>
+          <a:fillRef idx="3">
+            <a:schemeClr val="accent1"/>
+          </a:fillRef>
+          <a:effectRef idx="2">
+            <a:schemeClr val="accent1"/>
+          </a:effectRef>
+          <a:fontRef idx="minor">
+            <a:schemeClr val="lt1"/>
+          </a:fontRef>
+        </p:style>
+        <p:txBody>
+          <a:bodyPr rtlCol="0" anchor="ctr"/>
+          <a:lstStyle/>
+          <a:p>
+            <a:pPr algn="ctr"/>
+          </a:p>
+        </p:txBody>
+      </p:sp>
+      <p:sp>
+        <p:nvSpPr>
+          <p:cNvPr id="16" name="TextBox 15"/>
+          <p:cNvSpPr txBox="1"/>
+          <p:nvPr/>
+        </p:nvSpPr>
+        <p:spPr>
+          <a:xfrm>
+            <a:off x="548640" y="5120640"/>
+            <a:ext cx="11064240" cy="457200"/>
+          </a:xfrm>
+          <a:prstGeom prst="rect">
+            <a:avLst/>
+          </a:prstGeom>
+          <a:noFill/>
+        </p:spPr>
+        <p:txBody>
+          <a:bodyPr wrap="square" anchor="t" lIns="18288" rIns="18288" tIns="18288" bIns="18288">
+            <a:spAutoFit/>
+          </a:bodyPr>
+          <a:lstStyle/>
+          <a:p>
+            <a:pPr algn="l">
+              <a:spcAft>
+                <a:spcPts val="0"/>
+              </a:spcAft>
+            </a:pPr>
+            <a:r>
+              <a:rPr sz="1350" b="1">
+                <a:solidFill>
+                  <a:srgbClr val="0F2442"/>
+                </a:solidFill>
+                <a:latin typeface="Calibri"/>
+              </a:rPr>
+              <a:t>Exit criterion for each phase is a measured number on hardware — not a document.</a:t>
+            </a:r>
+          </a:p>
+        </p:txBody>
+      </p:sp>
+    </p:spTree>
+  </p:cSld>
+  <p:clrMapOvr>
+    <a:masterClrMapping/>
+  </p:clrMapOvr>
+</p:sld>
+</file>
+
+<file path=ppt/slides/slide17.xml><?xml version="1.0" encoding="utf-8"?>
+<p:sld xmlns:a="http://schemas.openxmlformats.org/drawingml/2006/main" xmlns:p="http://schemas.openxmlformats.org/presentationml/2006/main" xmlns:r="http://schemas.openxmlformats.org/officeDocument/2006/relationships">
+  <p:cSld>
+    <p:spTree>
+      <p:nvGrpSpPr>
+        <p:cNvPr id="1" name=""/>
+        <p:cNvGrpSpPr/>
+        <p:nvPr/>
+      </p:nvGrpSpPr>
+      <p:grpSpPr/>
+      <p:sp>
+        <p:nvSpPr>
+          <p:cNvPr id="2" name="Rectangle 1"/>
+          <p:cNvSpPr/>
+          <p:nvPr/>
+        </p:nvSpPr>
+        <p:spPr>
+          <a:xfrm>
+            <a:off x="0" y="0"/>
+            <a:ext cx="12191695" cy="6858000"/>
+          </a:xfrm>
+          <a:prstGeom prst="rect">
+            <a:avLst/>
+          </a:prstGeom>
+          <a:solidFill>
+            <a:srgbClr val="FFFFFF"/>
+          </a:solidFill>
+          <a:ln>
+            <a:noFill/>
+          </a:ln>
+          <a:effectLst/>
+        </p:spPr>
+        <p:style>
+          <a:lnRef idx="1">
+            <a:schemeClr val="accent1"/>
+          </a:lnRef>
+          <a:fillRef idx="3">
+            <a:schemeClr val="accent1"/>
+          </a:fillRef>
+          <a:effectRef idx="2">
+            <a:schemeClr val="accent1"/>
+          </a:effectRef>
+          <a:fontRef idx="minor">
+            <a:schemeClr val="lt1"/>
+          </a:fontRef>
+        </p:style>
+        <p:txBody>
+          <a:bodyPr rtlCol="0" anchor="ctr"/>
+          <a:lstStyle/>
+          <a:p>
+            <a:pPr algn="ctr"/>
+          </a:p>
+        </p:txBody>
+      </p:sp>
+      <p:sp>
+        <p:nvSpPr>
+          <p:cNvPr id="3" name="TextBox 2"/>
+          <p:cNvSpPr txBox="1"/>
+          <p:nvPr/>
+        </p:nvSpPr>
+        <p:spPr>
+          <a:xfrm>
+            <a:off x="548640" y="274320"/>
+            <a:ext cx="8229600" cy="274320"/>
+          </a:xfrm>
+          <a:prstGeom prst="rect">
+            <a:avLst/>
+          </a:prstGeom>
+          <a:noFill/>
+        </p:spPr>
+        <p:txBody>
+          <a:bodyPr wrap="square" anchor="t" lIns="18288" rIns="18288" tIns="18288" bIns="18288">
+            <a:spAutoFit/>
+          </a:bodyPr>
+          <a:lstStyle/>
+          <a:p>
+            <a:pPr algn="l">
+              <a:spcAft>
+                <a:spcPts val="0"/>
+              </a:spcAft>
+            </a:pPr>
+            <a:r>
+              <a:rPr sz="1100" b="1">
+                <a:solidFill>
+                  <a:srgbClr val="2E86AB"/>
+                </a:solidFill>
+                <a:latin typeface="Calibri"/>
+              </a:rPr>
+              <a:t>HONESTY</a:t>
+            </a:r>
+          </a:p>
+        </p:txBody>
+      </p:sp>
+      <p:sp>
+        <p:nvSpPr>
+          <p:cNvPr id="4" name="TextBox 3"/>
+          <p:cNvSpPr txBox="1"/>
+          <p:nvPr/>
+        </p:nvSpPr>
+        <p:spPr>
+          <a:xfrm>
+            <a:off x="548640" y="548640"/>
+            <a:ext cx="11091672" cy="548640"/>
+          </a:xfrm>
+          <a:prstGeom prst="rect">
+            <a:avLst/>
+          </a:prstGeom>
+          <a:noFill/>
+        </p:spPr>
+        <p:txBody>
+          <a:bodyPr wrap="square" anchor="t" lIns="18288" rIns="18288" tIns="18288" bIns="18288">
+            <a:spAutoFit/>
+          </a:bodyPr>
+          <a:lstStyle/>
+          <a:p>
+            <a:pPr algn="l">
+              <a:spcAft>
+                <a:spcPts val="0"/>
+              </a:spcAft>
+            </a:pPr>
+            <a:r>
+              <a:rPr sz="2600" b="1">
+                <a:solidFill>
+                  <a:srgbClr val="0F2442"/>
+                </a:solidFill>
+                <a:latin typeface="Calibri"/>
+              </a:rPr>
+              <a:t>Risks — stated, owned, and instrumented</a:t>
+            </a:r>
+          </a:p>
+        </p:txBody>
+      </p:sp>
+      <p:sp>
+        <p:nvSpPr>
+          <p:cNvPr id="5" name="Rectangle 4"/>
+          <p:cNvSpPr/>
+          <p:nvPr/>
+        </p:nvSpPr>
+        <p:spPr>
+          <a:xfrm>
+            <a:off x="548640" y="1078992"/>
+            <a:ext cx="1371600" cy="41148"/>
+          </a:xfrm>
+          <a:prstGeom prst="rect">
+            <a:avLst/>
+          </a:prstGeom>
+          <a:solidFill>
+            <a:srgbClr val="2E86AB"/>
+          </a:solidFill>
+          <a:ln>
+            <a:noFill/>
+          </a:ln>
+          <a:effectLst/>
+        </p:spPr>
+        <p:style>
+          <a:lnRef idx="1">
+            <a:schemeClr val="accent1"/>
+          </a:lnRef>
+          <a:fillRef idx="3">
+            <a:schemeClr val="accent1"/>
+          </a:fillRef>
+          <a:effectRef idx="2">
+            <a:schemeClr val="accent1"/>
+          </a:effectRef>
+          <a:fontRef idx="minor">
+            <a:schemeClr val="lt1"/>
+          </a:fontRef>
+        </p:style>
+        <p:txBody>
+          <a:bodyPr rtlCol="0" anchor="ctr"/>
+          <a:lstStyle/>
+          <a:p>
+            <a:pPr algn="ctr"/>
+          </a:p>
+        </p:txBody>
+      </p:sp>
+      <p:sp>
+        <p:nvSpPr>
+          <p:cNvPr id="6" name="TextBox 5"/>
+          <p:cNvSpPr txBox="1"/>
+          <p:nvPr/>
+        </p:nvSpPr>
+        <p:spPr>
+          <a:xfrm>
+            <a:off x="10911535" y="6473952"/>
+            <a:ext cx="822960" cy="274320"/>
+          </a:xfrm>
+          <a:prstGeom prst="rect">
+            <a:avLst/>
+          </a:prstGeom>
+          <a:noFill/>
+        </p:spPr>
+        <p:txBody>
+          <a:bodyPr wrap="square" anchor="t" lIns="18288" rIns="18288" tIns="18288" bIns="18288">
+            <a:spAutoFit/>
+          </a:bodyPr>
+          <a:lstStyle/>
+          <a:p>
+            <a:pPr algn="r">
+              <a:spcAft>
+                <a:spcPts val="0"/>
+              </a:spcAft>
+            </a:pPr>
+            <a:r>
+              <a:rPr sz="1000" b="0">
+                <a:solidFill>
+                  <a:srgbClr val="5B6676"/>
+                </a:solidFill>
+                <a:latin typeface="Calibri"/>
+              </a:rPr>
+              <a:t>17</a:t>
             </a:r>
           </a:p>
         </p:txBody>
@@ -7923,7 +9958,7 @@
 </p:sld>
 </file>
 
-<file path=ppt/slides/slide16.xml><?xml version="1.0" encoding="utf-8"?>
+<file path=ppt/slides/slide18.xml><?xml version="1.0" encoding="utf-8"?>
 <p:sld xmlns:a="http://schemas.openxmlformats.org/drawingml/2006/main" xmlns:p="http://schemas.openxmlformats.org/presentationml/2006/main" xmlns:r="http://schemas.openxmlformats.org/officeDocument/2006/relationships">
   <p:cSld>
     <p:spTree>

</xml_diff>